<commit_message>
UI updating: multiple batch selection logic and menu renaming
</commit_message>
<xml_diff>
--- a/doc/상세화면.pptx
+++ b/doc/상세화면.pptx
@@ -10,8 +10,10 @@
     <p:sldId id="272" r:id="rId4"/>
     <p:sldId id="273" r:id="rId5"/>
     <p:sldId id="276" r:id="rId6"/>
+    <p:sldId id="277" r:id="rId7"/>
+    <p:sldId id="278" r:id="rId8"/>
   </p:sldIdLst>
-  <p:sldSz cx="9144000" cy="6858000" type="screen4x3"/>
+  <p:sldSz cx="6858000" cy="9144000" type="screen4x3"/>
   <p:notesSz cx="6797675" cy="9928225"/>
   <p:defaultTextStyle>
     <a:defPPr>
@@ -110,7 +112,7 @@
   </p:defaultTextStyle>
   <p:extLst>
     <p:ext uri="{EFAFB233-063F-42B5-8137-9DF3F51BA10A}">
-      <p15:sldGuideLst xmlns:p15="http://schemas.microsoft.com/office/powerpoint/2012/main" xmlns="">
+      <p15:sldGuideLst xmlns="" xmlns:p15="http://schemas.microsoft.com/office/powerpoint/2012/main">
         <p15:guide id="1" orient="horz" pos="2160">
           <p15:clr>
             <a:srgbClr val="A4A3A4"/>
@@ -156,8 +158,8 @@
         </p:nvSpPr>
         <p:spPr>
           <a:xfrm>
-            <a:off x="685800" y="2130426"/>
-            <a:ext cx="7772400" cy="1470025"/>
+            <a:off x="514350" y="2840569"/>
+            <a:ext cx="5829300" cy="1960033"/>
           </a:xfrm>
         </p:spPr>
         <p:txBody>
@@ -184,8 +186,8 @@
         </p:nvSpPr>
         <p:spPr>
           <a:xfrm>
-            <a:off x="1371600" y="3886200"/>
-            <a:ext cx="6400800" cy="1752600"/>
+            <a:off x="1028700" y="5181600"/>
+            <a:ext cx="4800600" cy="2336800"/>
           </a:xfrm>
         </p:spPr>
         <p:txBody>
@@ -308,7 +310,7 @@
           <a:p>
             <a:fld id="{8B888A6C-3786-4323-9D2A-1673170D2C55}" type="datetimeFigureOut">
               <a:rPr lang="ko-KR" altLang="en-US" smtClean="0"/>
-              <a:t>2026-02-09</a:t>
+              <a:t>2026-04-13</a:t>
             </a:fld>
             <a:endParaRPr lang="ko-KR" altLang="en-US"/>
           </a:p>
@@ -478,7 +480,7 @@
           <a:p>
             <a:fld id="{8B888A6C-3786-4323-9D2A-1673170D2C55}" type="datetimeFigureOut">
               <a:rPr lang="ko-KR" altLang="en-US" smtClean="0"/>
-              <a:t>2026-02-09</a:t>
+              <a:t>2026-04-13</a:t>
             </a:fld>
             <a:endParaRPr lang="ko-KR" altLang="en-US"/>
           </a:p>
@@ -568,8 +570,8 @@
         </p:nvSpPr>
         <p:spPr>
           <a:xfrm>
-            <a:off x="6629400" y="274639"/>
-            <a:ext cx="2057400" cy="5851525"/>
+            <a:off x="4972050" y="366186"/>
+            <a:ext cx="1543050" cy="7802033"/>
           </a:xfrm>
         </p:spPr>
         <p:txBody>
@@ -596,8 +598,8 @@
         </p:nvSpPr>
         <p:spPr>
           <a:xfrm>
-            <a:off x="457200" y="274639"/>
-            <a:ext cx="6019800" cy="5851525"/>
+            <a:off x="342900" y="366186"/>
+            <a:ext cx="4514850" cy="7802033"/>
           </a:xfrm>
         </p:spPr>
         <p:txBody>
@@ -658,7 +660,7 @@
           <a:p>
             <a:fld id="{8B888A6C-3786-4323-9D2A-1673170D2C55}" type="datetimeFigureOut">
               <a:rPr lang="ko-KR" altLang="en-US" smtClean="0"/>
-              <a:t>2026-02-09</a:t>
+              <a:t>2026-04-13</a:t>
             </a:fld>
             <a:endParaRPr lang="ko-KR" altLang="en-US"/>
           </a:p>
@@ -828,7 +830,7 @@
           <a:p>
             <a:fld id="{8B888A6C-3786-4323-9D2A-1673170D2C55}" type="datetimeFigureOut">
               <a:rPr lang="ko-KR" altLang="en-US" smtClean="0"/>
-              <a:t>2026-02-09</a:t>
+              <a:t>2026-04-13</a:t>
             </a:fld>
             <a:endParaRPr lang="ko-KR" altLang="en-US"/>
           </a:p>
@@ -925,8 +927,8 @@
         </p:nvSpPr>
         <p:spPr>
           <a:xfrm>
-            <a:off x="722313" y="4406900"/>
-            <a:ext cx="7772400" cy="1362075"/>
+            <a:off x="541735" y="5875867"/>
+            <a:ext cx="5829300" cy="1816100"/>
           </a:xfrm>
         </p:spPr>
         <p:txBody>
@@ -957,8 +959,8 @@
         </p:nvSpPr>
         <p:spPr>
           <a:xfrm>
-            <a:off x="722313" y="2906714"/>
-            <a:ext cx="7772400" cy="1500187"/>
+            <a:off x="541735" y="3875620"/>
+            <a:ext cx="5829300" cy="2000249"/>
           </a:xfrm>
         </p:spPr>
         <p:txBody>
@@ -1081,7 +1083,7 @@
           <a:p>
             <a:fld id="{8B888A6C-3786-4323-9D2A-1673170D2C55}" type="datetimeFigureOut">
               <a:rPr lang="ko-KR" altLang="en-US" smtClean="0"/>
-              <a:t>2026-02-09</a:t>
+              <a:t>2026-04-13</a:t>
             </a:fld>
             <a:endParaRPr lang="ko-KR" altLang="en-US"/>
           </a:p>
@@ -1194,8 +1196,8 @@
         </p:nvSpPr>
         <p:spPr>
           <a:xfrm>
-            <a:off x="457200" y="1600201"/>
-            <a:ext cx="4038600" cy="4525963"/>
+            <a:off x="342900" y="2133602"/>
+            <a:ext cx="3028950" cy="6034617"/>
           </a:xfrm>
         </p:spPr>
         <p:txBody>
@@ -1279,8 +1281,8 @@
         </p:nvSpPr>
         <p:spPr>
           <a:xfrm>
-            <a:off x="4648200" y="1600201"/>
-            <a:ext cx="4038600" cy="4525963"/>
+            <a:off x="3486150" y="2133602"/>
+            <a:ext cx="3028950" cy="6034617"/>
           </a:xfrm>
         </p:spPr>
         <p:txBody>
@@ -1369,7 +1371,7 @@
           <a:p>
             <a:fld id="{8B888A6C-3786-4323-9D2A-1673170D2C55}" type="datetimeFigureOut">
               <a:rPr lang="ko-KR" altLang="en-US" smtClean="0"/>
-              <a:t>2026-02-09</a:t>
+              <a:t>2026-04-13</a:t>
             </a:fld>
             <a:endParaRPr lang="ko-KR" altLang="en-US"/>
           </a:p>
@@ -1486,8 +1488,8 @@
         </p:nvSpPr>
         <p:spPr>
           <a:xfrm>
-            <a:off x="457201" y="1535113"/>
-            <a:ext cx="4040188" cy="639762"/>
+            <a:off x="342901" y="2046817"/>
+            <a:ext cx="3030141" cy="853016"/>
           </a:xfrm>
         </p:spPr>
         <p:txBody>
@@ -1551,8 +1553,8 @@
         </p:nvSpPr>
         <p:spPr>
           <a:xfrm>
-            <a:off x="457201" y="2174875"/>
-            <a:ext cx="4040188" cy="3951288"/>
+            <a:off x="342901" y="2899833"/>
+            <a:ext cx="3030141" cy="5268384"/>
           </a:xfrm>
         </p:spPr>
         <p:txBody>
@@ -1636,8 +1638,8 @@
         </p:nvSpPr>
         <p:spPr>
           <a:xfrm>
-            <a:off x="4645026" y="1535113"/>
-            <a:ext cx="4041775" cy="639762"/>
+            <a:off x="3483770" y="2046817"/>
+            <a:ext cx="3031331" cy="853016"/>
           </a:xfrm>
         </p:spPr>
         <p:txBody>
@@ -1701,8 +1703,8 @@
         </p:nvSpPr>
         <p:spPr>
           <a:xfrm>
-            <a:off x="4645026" y="2174875"/>
-            <a:ext cx="4041775" cy="3951288"/>
+            <a:off x="3483770" y="2899833"/>
+            <a:ext cx="3031331" cy="5268384"/>
           </a:xfrm>
         </p:spPr>
         <p:txBody>
@@ -1791,7 +1793,7 @@
           <a:p>
             <a:fld id="{8B888A6C-3786-4323-9D2A-1673170D2C55}" type="datetimeFigureOut">
               <a:rPr lang="ko-KR" altLang="en-US" smtClean="0"/>
-              <a:t>2026-02-09</a:t>
+              <a:t>2026-04-13</a:t>
             </a:fld>
             <a:endParaRPr lang="ko-KR" altLang="en-US"/>
           </a:p>
@@ -1909,7 +1911,7 @@
           <a:p>
             <a:fld id="{8B888A6C-3786-4323-9D2A-1673170D2C55}" type="datetimeFigureOut">
               <a:rPr lang="ko-KR" altLang="en-US" smtClean="0"/>
-              <a:t>2026-02-09</a:t>
+              <a:t>2026-04-13</a:t>
             </a:fld>
             <a:endParaRPr lang="ko-KR" altLang="en-US"/>
           </a:p>
@@ -2004,7 +2006,7 @@
           <a:p>
             <a:fld id="{8B888A6C-3786-4323-9D2A-1673170D2C55}" type="datetimeFigureOut">
               <a:rPr lang="ko-KR" altLang="en-US" smtClean="0"/>
-              <a:t>2026-02-09</a:t>
+              <a:t>2026-04-13</a:t>
             </a:fld>
             <a:endParaRPr lang="ko-KR" altLang="en-US"/>
           </a:p>
@@ -2094,8 +2096,8 @@
         </p:nvSpPr>
         <p:spPr>
           <a:xfrm>
-            <a:off x="457201" y="273050"/>
-            <a:ext cx="3008313" cy="1162050"/>
+            <a:off x="342901" y="364067"/>
+            <a:ext cx="2256235" cy="1549400"/>
           </a:xfrm>
         </p:spPr>
         <p:txBody>
@@ -2126,8 +2128,8 @@
         </p:nvSpPr>
         <p:spPr>
           <a:xfrm>
-            <a:off x="3575050" y="273051"/>
-            <a:ext cx="5111751" cy="5853113"/>
+            <a:off x="2681288" y="364069"/>
+            <a:ext cx="3833813" cy="7804151"/>
           </a:xfrm>
         </p:spPr>
         <p:txBody>
@@ -2211,8 +2213,8 @@
         </p:nvSpPr>
         <p:spPr>
           <a:xfrm>
-            <a:off x="457201" y="1435101"/>
-            <a:ext cx="3008313" cy="4691063"/>
+            <a:off x="342901" y="1913469"/>
+            <a:ext cx="2256235" cy="6254751"/>
           </a:xfrm>
         </p:spPr>
         <p:txBody>
@@ -2281,7 +2283,7 @@
           <a:p>
             <a:fld id="{8B888A6C-3786-4323-9D2A-1673170D2C55}" type="datetimeFigureOut">
               <a:rPr lang="ko-KR" altLang="en-US" smtClean="0"/>
-              <a:t>2026-02-09</a:t>
+              <a:t>2026-04-13</a:t>
             </a:fld>
             <a:endParaRPr lang="ko-KR" altLang="en-US"/>
           </a:p>
@@ -2371,8 +2373,8 @@
         </p:nvSpPr>
         <p:spPr>
           <a:xfrm>
-            <a:off x="1792288" y="4800601"/>
-            <a:ext cx="5486400" cy="566738"/>
+            <a:off x="1344216" y="6400801"/>
+            <a:ext cx="4114800" cy="755651"/>
           </a:xfrm>
         </p:spPr>
         <p:txBody>
@@ -2403,8 +2405,8 @@
         </p:nvSpPr>
         <p:spPr>
           <a:xfrm>
-            <a:off x="1792288" y="612775"/>
-            <a:ext cx="5486400" cy="4114800"/>
+            <a:off x="1344216" y="817033"/>
+            <a:ext cx="4114800" cy="5486400"/>
           </a:xfrm>
         </p:spPr>
         <p:txBody>
@@ -2464,8 +2466,8 @@
         </p:nvSpPr>
         <p:spPr>
           <a:xfrm>
-            <a:off x="1792288" y="5367339"/>
-            <a:ext cx="5486400" cy="804862"/>
+            <a:off x="1344216" y="7156452"/>
+            <a:ext cx="4114800" cy="1073149"/>
           </a:xfrm>
         </p:spPr>
         <p:txBody>
@@ -2534,7 +2536,7 @@
           <a:p>
             <a:fld id="{8B888A6C-3786-4323-9D2A-1673170D2C55}" type="datetimeFigureOut">
               <a:rPr lang="ko-KR" altLang="en-US" smtClean="0"/>
-              <a:t>2026-02-09</a:t>
+              <a:t>2026-04-13</a:t>
             </a:fld>
             <a:endParaRPr lang="ko-KR" altLang="en-US"/>
           </a:p>
@@ -2629,8 +2631,8 @@
         </p:nvSpPr>
         <p:spPr>
           <a:xfrm>
-            <a:off x="457200" y="274638"/>
-            <a:ext cx="8229600" cy="1143000"/>
+            <a:off x="342900" y="366184"/>
+            <a:ext cx="6172200" cy="1524000"/>
           </a:xfrm>
           <a:prstGeom prst="rect">
             <a:avLst/>
@@ -2662,8 +2664,8 @@
         </p:nvSpPr>
         <p:spPr>
           <a:xfrm>
-            <a:off x="457200" y="1600201"/>
-            <a:ext cx="8229600" cy="4525963"/>
+            <a:off x="342900" y="2133602"/>
+            <a:ext cx="6172200" cy="6034617"/>
           </a:xfrm>
           <a:prstGeom prst="rect">
             <a:avLst/>
@@ -2724,8 +2726,8 @@
         </p:nvSpPr>
         <p:spPr>
           <a:xfrm>
-            <a:off x="457200" y="6356351"/>
-            <a:ext cx="2133600" cy="365125"/>
+            <a:off x="342900" y="8475136"/>
+            <a:ext cx="1600200" cy="486833"/>
           </a:xfrm>
           <a:prstGeom prst="rect">
             <a:avLst/>
@@ -2747,7 +2749,7 @@
           <a:p>
             <a:fld id="{8B888A6C-3786-4323-9D2A-1673170D2C55}" type="datetimeFigureOut">
               <a:rPr lang="ko-KR" altLang="en-US" smtClean="0"/>
-              <a:t>2026-02-09</a:t>
+              <a:t>2026-04-13</a:t>
             </a:fld>
             <a:endParaRPr lang="ko-KR" altLang="en-US"/>
           </a:p>
@@ -2765,8 +2767,8 @@
         </p:nvSpPr>
         <p:spPr>
           <a:xfrm>
-            <a:off x="3124200" y="6356351"/>
-            <a:ext cx="2895600" cy="365125"/>
+            <a:off x="2343150" y="8475136"/>
+            <a:ext cx="2171700" cy="486833"/>
           </a:xfrm>
           <a:prstGeom prst="rect">
             <a:avLst/>
@@ -2802,8 +2804,8 @@
         </p:nvSpPr>
         <p:spPr>
           <a:xfrm>
-            <a:off x="6553200" y="6356351"/>
-            <a:ext cx="2133600" cy="365125"/>
+            <a:off x="4914900" y="8475136"/>
+            <a:ext cx="1600200" cy="486833"/>
           </a:xfrm>
           <a:prstGeom prst="rect">
             <a:avLst/>
@@ -3130,8 +3132,8 @@
         </p:nvSpPr>
         <p:spPr>
           <a:xfrm>
-            <a:off x="611560" y="1772816"/>
-            <a:ext cx="3924436" cy="4320480"/>
+            <a:off x="458670" y="2363755"/>
+            <a:ext cx="2943327" cy="5760640"/>
           </a:xfrm>
           <a:prstGeom prst="rect">
             <a:avLst/>
@@ -3171,8 +3173,8 @@
         </p:nvSpPr>
         <p:spPr>
           <a:xfrm>
-            <a:off x="611560" y="116632"/>
-            <a:ext cx="3024336" cy="369332"/>
+            <a:off x="458670" y="155509"/>
+            <a:ext cx="2268252" cy="646331"/>
           </a:xfrm>
           <a:prstGeom prst="rect">
             <a:avLst/>
@@ -3201,8 +3203,8 @@
         </p:nvSpPr>
         <p:spPr>
           <a:xfrm>
-            <a:off x="611560" y="620688"/>
-            <a:ext cx="3924436" cy="1152128"/>
+            <a:off x="458670" y="827584"/>
+            <a:ext cx="2943327" cy="1536171"/>
           </a:xfrm>
           <a:prstGeom prst="rect">
             <a:avLst/>
@@ -3242,8 +3244,8 @@
         </p:nvSpPr>
         <p:spPr>
           <a:xfrm>
-            <a:off x="4535996" y="620688"/>
-            <a:ext cx="3924436" cy="5472608"/>
+            <a:off x="3401997" y="827584"/>
+            <a:ext cx="2943327" cy="7296811"/>
           </a:xfrm>
           <a:prstGeom prst="rect">
             <a:avLst/>
@@ -3283,8 +3285,8 @@
         </p:nvSpPr>
         <p:spPr>
           <a:xfrm>
-            <a:off x="899592" y="1012086"/>
-            <a:ext cx="3024336" cy="369332"/>
+            <a:off x="674694" y="1349448"/>
+            <a:ext cx="2268252" cy="369332"/>
           </a:xfrm>
           <a:prstGeom prst="rect">
             <a:avLst/>
@@ -3314,8 +3316,8 @@
         </p:nvSpPr>
         <p:spPr>
           <a:xfrm>
-            <a:off x="899592" y="3451518"/>
-            <a:ext cx="3024336" cy="369332"/>
+            <a:off x="674694" y="4602024"/>
+            <a:ext cx="2268252" cy="369332"/>
           </a:xfrm>
           <a:prstGeom prst="rect">
             <a:avLst/>
@@ -3345,8 +3347,8 @@
         </p:nvSpPr>
         <p:spPr>
           <a:xfrm>
-            <a:off x="5076056" y="3276670"/>
-            <a:ext cx="3024336" cy="369332"/>
+            <a:off x="3807042" y="4368893"/>
+            <a:ext cx="2268252" cy="369332"/>
           </a:xfrm>
           <a:prstGeom prst="rect">
             <a:avLst/>
@@ -3406,8 +3408,8 @@
         </p:nvSpPr>
         <p:spPr>
           <a:xfrm>
-            <a:off x="1098594" y="836712"/>
-            <a:ext cx="936104" cy="360040"/>
+            <a:off x="823946" y="1115616"/>
+            <a:ext cx="702078" cy="480053"/>
           </a:xfrm>
           <a:prstGeom prst="rect">
             <a:avLst/>
@@ -3461,8 +3463,8 @@
         </p:nvSpPr>
         <p:spPr>
           <a:xfrm>
-            <a:off x="2430742" y="836712"/>
-            <a:ext cx="1656184" cy="360040"/>
+            <a:off x="1823057" y="1115616"/>
+            <a:ext cx="1242138" cy="480053"/>
           </a:xfrm>
           <a:prstGeom prst="rect">
             <a:avLst/>
@@ -3505,8 +3507,8 @@
         </p:nvSpPr>
         <p:spPr>
           <a:xfrm>
-            <a:off x="1098594" y="1340768"/>
-            <a:ext cx="936104" cy="360040"/>
+            <a:off x="823946" y="1787691"/>
+            <a:ext cx="702078" cy="480053"/>
           </a:xfrm>
           <a:prstGeom prst="rect">
             <a:avLst/>
@@ -3560,8 +3562,8 @@
         </p:nvSpPr>
         <p:spPr>
           <a:xfrm>
-            <a:off x="2430742" y="1340768"/>
-            <a:ext cx="1656184" cy="360040"/>
+            <a:off x="1823057" y="1787691"/>
+            <a:ext cx="1242138" cy="480053"/>
           </a:xfrm>
           <a:prstGeom prst="rect">
             <a:avLst/>
@@ -3604,8 +3606,8 @@
         </p:nvSpPr>
         <p:spPr>
           <a:xfrm>
-            <a:off x="1098594" y="1844824"/>
-            <a:ext cx="936104" cy="360040"/>
+            <a:off x="823946" y="2459766"/>
+            <a:ext cx="702078" cy="480053"/>
           </a:xfrm>
           <a:prstGeom prst="rect">
             <a:avLst/>
@@ -3659,8 +3661,8 @@
         </p:nvSpPr>
         <p:spPr>
           <a:xfrm>
-            <a:off x="2430742" y="1844824"/>
-            <a:ext cx="1656184" cy="360040"/>
+            <a:off x="1823057" y="2459766"/>
+            <a:ext cx="1242138" cy="480053"/>
           </a:xfrm>
           <a:prstGeom prst="rect">
             <a:avLst/>
@@ -3703,8 +3705,8 @@
         </p:nvSpPr>
         <p:spPr>
           <a:xfrm>
-            <a:off x="1098594" y="2348880"/>
-            <a:ext cx="936104" cy="360040"/>
+            <a:off x="823946" y="3131840"/>
+            <a:ext cx="702078" cy="480053"/>
           </a:xfrm>
           <a:prstGeom prst="rect">
             <a:avLst/>
@@ -3766,8 +3768,8 @@
         </p:nvSpPr>
         <p:spPr>
           <a:xfrm>
-            <a:off x="2430742" y="2348880"/>
-            <a:ext cx="360040" cy="360040"/>
+            <a:off x="1823057" y="3131840"/>
+            <a:ext cx="270030" cy="480053"/>
           </a:xfrm>
           <a:prstGeom prst="rect">
             <a:avLst/>
@@ -3810,8 +3812,8 @@
         </p:nvSpPr>
         <p:spPr>
           <a:xfrm>
-            <a:off x="1098594" y="2852936"/>
-            <a:ext cx="936104" cy="360040"/>
+            <a:off x="823946" y="3803915"/>
+            <a:ext cx="702078" cy="480053"/>
           </a:xfrm>
           <a:prstGeom prst="rect">
             <a:avLst/>
@@ -3873,8 +3875,8 @@
         </p:nvSpPr>
         <p:spPr>
           <a:xfrm>
-            <a:off x="2430742" y="2852936"/>
-            <a:ext cx="360040" cy="360040"/>
+            <a:off x="1823057" y="3803915"/>
+            <a:ext cx="270030" cy="480053"/>
           </a:xfrm>
           <a:prstGeom prst="rect">
             <a:avLst/>
@@ -3917,8 +3919,8 @@
         </p:nvSpPr>
         <p:spPr>
           <a:xfrm>
-            <a:off x="1098594" y="3356992"/>
-            <a:ext cx="936104" cy="360040"/>
+            <a:off x="823946" y="4475989"/>
+            <a:ext cx="702078" cy="480053"/>
           </a:xfrm>
           <a:prstGeom prst="rect">
             <a:avLst/>
@@ -3980,8 +3982,8 @@
         </p:nvSpPr>
         <p:spPr>
           <a:xfrm>
-            <a:off x="2430742" y="3356992"/>
-            <a:ext cx="360040" cy="360040"/>
+            <a:off x="1823057" y="4475989"/>
+            <a:ext cx="270030" cy="480053"/>
           </a:xfrm>
           <a:prstGeom prst="rect">
             <a:avLst/>
@@ -4024,8 +4026,8 @@
         </p:nvSpPr>
         <p:spPr>
           <a:xfrm>
-            <a:off x="4987026" y="836712"/>
-            <a:ext cx="936104" cy="360040"/>
+            <a:off x="3740270" y="1115616"/>
+            <a:ext cx="702078" cy="480053"/>
           </a:xfrm>
           <a:prstGeom prst="rect">
             <a:avLst/>
@@ -4079,8 +4081,8 @@
         </p:nvSpPr>
         <p:spPr>
           <a:xfrm>
-            <a:off x="6319174" y="836712"/>
-            <a:ext cx="1656184" cy="360040"/>
+            <a:off x="4739381" y="1115616"/>
+            <a:ext cx="1242138" cy="480053"/>
           </a:xfrm>
           <a:prstGeom prst="rect">
             <a:avLst/>
@@ -4123,8 +4125,8 @@
         </p:nvSpPr>
         <p:spPr>
           <a:xfrm>
-            <a:off x="4987026" y="1340768"/>
-            <a:ext cx="936104" cy="360040"/>
+            <a:off x="3740270" y="1787691"/>
+            <a:ext cx="702078" cy="480053"/>
           </a:xfrm>
           <a:prstGeom prst="rect">
             <a:avLst/>
@@ -4178,8 +4180,8 @@
         </p:nvSpPr>
         <p:spPr>
           <a:xfrm>
-            <a:off x="6319174" y="1340768"/>
-            <a:ext cx="1656184" cy="360040"/>
+            <a:off x="4739381" y="1787691"/>
+            <a:ext cx="1242138" cy="480053"/>
           </a:xfrm>
           <a:prstGeom prst="rect">
             <a:avLst/>
@@ -4222,8 +4224,8 @@
         </p:nvSpPr>
         <p:spPr>
           <a:xfrm>
-            <a:off x="4987026" y="1844824"/>
-            <a:ext cx="936104" cy="360040"/>
+            <a:off x="3740270" y="2459766"/>
+            <a:ext cx="702078" cy="480053"/>
           </a:xfrm>
           <a:prstGeom prst="rect">
             <a:avLst/>
@@ -4277,8 +4279,8 @@
         </p:nvSpPr>
         <p:spPr>
           <a:xfrm>
-            <a:off x="6319174" y="1844824"/>
-            <a:ext cx="1656184" cy="360040"/>
+            <a:off x="4739381" y="2459766"/>
+            <a:ext cx="1242138" cy="480053"/>
           </a:xfrm>
           <a:prstGeom prst="rect">
             <a:avLst/>
@@ -4321,8 +4323,8 @@
         </p:nvSpPr>
         <p:spPr>
           <a:xfrm>
-            <a:off x="2934798" y="2348880"/>
-            <a:ext cx="1152128" cy="360040"/>
+            <a:off x="2201099" y="3131840"/>
+            <a:ext cx="864096" cy="480053"/>
           </a:xfrm>
           <a:prstGeom prst="rect">
             <a:avLst/>
@@ -4365,8 +4367,8 @@
         </p:nvSpPr>
         <p:spPr>
           <a:xfrm>
-            <a:off x="2934798" y="2852936"/>
-            <a:ext cx="1152128" cy="360040"/>
+            <a:off x="2201099" y="3803915"/>
+            <a:ext cx="864096" cy="480053"/>
           </a:xfrm>
           <a:prstGeom prst="rect">
             <a:avLst/>
@@ -4409,8 +4411,8 @@
         </p:nvSpPr>
         <p:spPr>
           <a:xfrm>
-            <a:off x="2934798" y="3356992"/>
-            <a:ext cx="1152128" cy="360040"/>
+            <a:off x="2201099" y="4475989"/>
+            <a:ext cx="864096" cy="480053"/>
           </a:xfrm>
           <a:prstGeom prst="rect">
             <a:avLst/>
@@ -4453,8 +4455,8 @@
         </p:nvSpPr>
         <p:spPr>
           <a:xfrm>
-            <a:off x="5003546" y="2380940"/>
-            <a:ext cx="936104" cy="360040"/>
+            <a:off x="3752660" y="3174587"/>
+            <a:ext cx="702078" cy="480053"/>
           </a:xfrm>
           <a:prstGeom prst="rect">
             <a:avLst/>
@@ -4511,8 +4513,8 @@
         </p:nvSpPr>
         <p:spPr>
           <a:xfrm>
-            <a:off x="6335694" y="2374280"/>
-            <a:ext cx="1656184" cy="334640"/>
+            <a:off x="4751771" y="3165707"/>
+            <a:ext cx="1242138" cy="446187"/>
           </a:xfrm>
           <a:prstGeom prst="rect">
             <a:avLst/>
@@ -4555,8 +4557,8 @@
         </p:nvSpPr>
         <p:spPr>
           <a:xfrm>
-            <a:off x="5003546" y="3063292"/>
-            <a:ext cx="936104" cy="360040"/>
+            <a:off x="3752660" y="4084390"/>
+            <a:ext cx="702078" cy="480053"/>
           </a:xfrm>
           <a:prstGeom prst="rect">
             <a:avLst/>
@@ -4610,8 +4612,8 @@
         </p:nvSpPr>
         <p:spPr>
           <a:xfrm>
-            <a:off x="6335694" y="2852936"/>
-            <a:ext cx="504056" cy="360040"/>
+            <a:off x="4751771" y="3803915"/>
+            <a:ext cx="378042" cy="480053"/>
           </a:xfrm>
           <a:prstGeom prst="rect">
             <a:avLst/>
@@ -4654,8 +4656,8 @@
         </p:nvSpPr>
         <p:spPr>
           <a:xfrm>
-            <a:off x="6917910" y="2852936"/>
-            <a:ext cx="1073968" cy="360040"/>
+            <a:off x="5188433" y="3803915"/>
+            <a:ext cx="805476" cy="480053"/>
           </a:xfrm>
           <a:prstGeom prst="rect">
             <a:avLst/>
@@ -4698,8 +4700,8 @@
         </p:nvSpPr>
         <p:spPr>
           <a:xfrm>
-            <a:off x="6335694" y="3356992"/>
-            <a:ext cx="1674688" cy="360040"/>
+            <a:off x="4751771" y="4475989"/>
+            <a:ext cx="1256016" cy="480053"/>
           </a:xfrm>
           <a:prstGeom prst="rect">
             <a:avLst/>
@@ -4742,8 +4744,8 @@
         </p:nvSpPr>
         <p:spPr>
           <a:xfrm>
-            <a:off x="1098594" y="4595440"/>
-            <a:ext cx="2988332" cy="2016224"/>
+            <a:off x="823946" y="6127253"/>
+            <a:ext cx="2241249" cy="2688299"/>
           </a:xfrm>
           <a:prstGeom prst="rect">
             <a:avLst/>
@@ -4786,8 +4788,8 @@
         </p:nvSpPr>
         <p:spPr>
           <a:xfrm>
-            <a:off x="1098594" y="4221088"/>
-            <a:ext cx="936104" cy="360040"/>
+            <a:off x="823946" y="5628118"/>
+            <a:ext cx="702078" cy="480053"/>
           </a:xfrm>
           <a:prstGeom prst="rect">
             <a:avLst/>
@@ -4849,8 +4851,8 @@
         </p:nvSpPr>
         <p:spPr>
           <a:xfrm>
-            <a:off x="5051618" y="4595440"/>
-            <a:ext cx="2988332" cy="2016224"/>
+            <a:off x="3788714" y="6127253"/>
+            <a:ext cx="2241249" cy="2688299"/>
           </a:xfrm>
           <a:prstGeom prst="rect">
             <a:avLst/>
@@ -4893,8 +4895,8 @@
         </p:nvSpPr>
         <p:spPr>
           <a:xfrm>
-            <a:off x="5051618" y="4221088"/>
-            <a:ext cx="936104" cy="360040"/>
+            <a:off x="3788714" y="5628118"/>
+            <a:ext cx="702078" cy="480053"/>
           </a:xfrm>
           <a:prstGeom prst="rect">
             <a:avLst/>
@@ -4956,8 +4958,8 @@
         </p:nvSpPr>
         <p:spPr>
           <a:xfrm>
-            <a:off x="611560" y="620688"/>
-            <a:ext cx="7848872" cy="6120680"/>
+            <a:off x="458670" y="827584"/>
+            <a:ext cx="5886654" cy="8160907"/>
           </a:xfrm>
           <a:prstGeom prst="rect">
             <a:avLst/>
@@ -4997,8 +4999,8 @@
         </p:nvSpPr>
         <p:spPr>
           <a:xfrm>
-            <a:off x="611560" y="116632"/>
-            <a:ext cx="3024336" cy="369332"/>
+            <a:off x="458670" y="155509"/>
+            <a:ext cx="2268252" cy="369332"/>
           </a:xfrm>
           <a:prstGeom prst="rect">
             <a:avLst/>
@@ -5027,8 +5029,8 @@
         </p:nvSpPr>
         <p:spPr>
           <a:xfrm>
-            <a:off x="5939650" y="116632"/>
-            <a:ext cx="900100" cy="369332"/>
+            <a:off x="4454738" y="155509"/>
+            <a:ext cx="675075" cy="492443"/>
           </a:xfrm>
           <a:prstGeom prst="roundRect">
             <a:avLst/>
@@ -5074,8 +5076,8 @@
         </p:nvSpPr>
         <p:spPr>
           <a:xfrm>
-            <a:off x="6917910" y="116632"/>
-            <a:ext cx="900100" cy="369332"/>
+            <a:off x="5188433" y="155509"/>
+            <a:ext cx="675075" cy="492443"/>
           </a:xfrm>
           <a:prstGeom prst="roundRect">
             <a:avLst/>
@@ -5118,8 +5120,8 @@
         </p:nvSpPr>
         <p:spPr>
           <a:xfrm>
-            <a:off x="4355976" y="116632"/>
-            <a:ext cx="1404156" cy="369332"/>
+            <a:off x="3266982" y="155509"/>
+            <a:ext cx="1053117" cy="492443"/>
           </a:xfrm>
           <a:prstGeom prst="roundRect">
             <a:avLst/>
@@ -5162,8 +5164,8 @@
         </p:nvSpPr>
         <p:spPr>
           <a:xfrm>
-            <a:off x="1098594" y="3831580"/>
-            <a:ext cx="936104" cy="360040"/>
+            <a:off x="823946" y="5108774"/>
+            <a:ext cx="702078" cy="480053"/>
           </a:xfrm>
           <a:prstGeom prst="rect">
             <a:avLst/>
@@ -5217,8 +5219,8 @@
         </p:nvSpPr>
         <p:spPr>
           <a:xfrm>
-            <a:off x="2425700" y="3831580"/>
-            <a:ext cx="1661226" cy="360040"/>
+            <a:off x="1819275" y="5108774"/>
+            <a:ext cx="1245920" cy="480053"/>
           </a:xfrm>
           <a:prstGeom prst="rect">
             <a:avLst/>
@@ -5291,8 +5293,8 @@
         </p:nvSpPr>
         <p:spPr>
           <a:xfrm>
-            <a:off x="611560" y="1772816"/>
-            <a:ext cx="3924436" cy="4320480"/>
+            <a:off x="458670" y="2363755"/>
+            <a:ext cx="2943327" cy="5760640"/>
           </a:xfrm>
           <a:prstGeom prst="rect">
             <a:avLst/>
@@ -5332,8 +5334,8 @@
         </p:nvSpPr>
         <p:spPr>
           <a:xfrm>
-            <a:off x="611560" y="116632"/>
-            <a:ext cx="3024336" cy="369332"/>
+            <a:off x="458670" y="155509"/>
+            <a:ext cx="2268252" cy="646331"/>
           </a:xfrm>
           <a:prstGeom prst="rect">
             <a:avLst/>
@@ -5362,8 +5364,8 @@
         </p:nvSpPr>
         <p:spPr>
           <a:xfrm>
-            <a:off x="611560" y="620688"/>
-            <a:ext cx="3924436" cy="1152128"/>
+            <a:off x="458670" y="827584"/>
+            <a:ext cx="2943327" cy="1536171"/>
           </a:xfrm>
           <a:prstGeom prst="rect">
             <a:avLst/>
@@ -5403,8 +5405,8 @@
         </p:nvSpPr>
         <p:spPr>
           <a:xfrm>
-            <a:off x="4535996" y="620688"/>
-            <a:ext cx="3924436" cy="5472608"/>
+            <a:off x="3401997" y="827584"/>
+            <a:ext cx="2943327" cy="7296811"/>
           </a:xfrm>
           <a:prstGeom prst="rect">
             <a:avLst/>
@@ -5444,8 +5446,8 @@
         </p:nvSpPr>
         <p:spPr>
           <a:xfrm>
-            <a:off x="899592" y="1012086"/>
-            <a:ext cx="3024336" cy="369332"/>
+            <a:off x="674694" y="1349448"/>
+            <a:ext cx="2268252" cy="369332"/>
           </a:xfrm>
           <a:prstGeom prst="rect">
             <a:avLst/>
@@ -5475,8 +5477,8 @@
         </p:nvSpPr>
         <p:spPr>
           <a:xfrm>
-            <a:off x="899592" y="3451518"/>
-            <a:ext cx="3024336" cy="369332"/>
+            <a:off x="674694" y="4602024"/>
+            <a:ext cx="2268252" cy="369332"/>
           </a:xfrm>
           <a:prstGeom prst="rect">
             <a:avLst/>
@@ -5506,8 +5508,8 @@
         </p:nvSpPr>
         <p:spPr>
           <a:xfrm>
-            <a:off x="5076056" y="3276670"/>
-            <a:ext cx="3024336" cy="369332"/>
+            <a:off x="3807042" y="4368893"/>
+            <a:ext cx="2268252" cy="369332"/>
           </a:xfrm>
           <a:prstGeom prst="rect">
             <a:avLst/>
@@ -5567,8 +5569,8 @@
         </p:nvSpPr>
         <p:spPr>
           <a:xfrm>
-            <a:off x="1098594" y="836712"/>
-            <a:ext cx="936104" cy="360040"/>
+            <a:off x="823946" y="1115616"/>
+            <a:ext cx="702078" cy="480053"/>
           </a:xfrm>
           <a:prstGeom prst="rect">
             <a:avLst/>
@@ -5622,8 +5624,8 @@
         </p:nvSpPr>
         <p:spPr>
           <a:xfrm>
-            <a:off x="2430742" y="836712"/>
-            <a:ext cx="1656184" cy="360040"/>
+            <a:off x="1823057" y="1115616"/>
+            <a:ext cx="1242138" cy="480053"/>
           </a:xfrm>
           <a:prstGeom prst="rect">
             <a:avLst/>
@@ -5666,8 +5668,8 @@
         </p:nvSpPr>
         <p:spPr>
           <a:xfrm>
-            <a:off x="1098594" y="1340768"/>
-            <a:ext cx="936104" cy="360040"/>
+            <a:off x="823946" y="1787691"/>
+            <a:ext cx="702078" cy="480053"/>
           </a:xfrm>
           <a:prstGeom prst="rect">
             <a:avLst/>
@@ -5721,8 +5723,8 @@
         </p:nvSpPr>
         <p:spPr>
           <a:xfrm>
-            <a:off x="2430742" y="1340768"/>
-            <a:ext cx="1656184" cy="360040"/>
+            <a:off x="1823057" y="1787691"/>
+            <a:ext cx="1242138" cy="480053"/>
           </a:xfrm>
           <a:prstGeom prst="rect">
             <a:avLst/>
@@ -5765,8 +5767,8 @@
         </p:nvSpPr>
         <p:spPr>
           <a:xfrm>
-            <a:off x="1098594" y="1844824"/>
-            <a:ext cx="936104" cy="360040"/>
+            <a:off x="823946" y="2459766"/>
+            <a:ext cx="702078" cy="480053"/>
           </a:xfrm>
           <a:prstGeom prst="rect">
             <a:avLst/>
@@ -5820,8 +5822,8 @@
         </p:nvSpPr>
         <p:spPr>
           <a:xfrm>
-            <a:off x="2430742" y="1844824"/>
-            <a:ext cx="1656184" cy="360040"/>
+            <a:off x="1823057" y="2459766"/>
+            <a:ext cx="1242138" cy="480053"/>
           </a:xfrm>
           <a:prstGeom prst="rect">
             <a:avLst/>
@@ -5864,8 +5866,8 @@
         </p:nvSpPr>
         <p:spPr>
           <a:xfrm>
-            <a:off x="1098594" y="2348880"/>
-            <a:ext cx="936104" cy="360040"/>
+            <a:off x="823946" y="3131840"/>
+            <a:ext cx="702078" cy="480053"/>
           </a:xfrm>
           <a:prstGeom prst="rect">
             <a:avLst/>
@@ -5919,8 +5921,8 @@
         </p:nvSpPr>
         <p:spPr>
           <a:xfrm>
-            <a:off x="4987026" y="836712"/>
-            <a:ext cx="936104" cy="360040"/>
+            <a:off x="3740270" y="1115616"/>
+            <a:ext cx="702078" cy="480053"/>
           </a:xfrm>
           <a:prstGeom prst="rect">
             <a:avLst/>
@@ -5974,8 +5976,8 @@
         </p:nvSpPr>
         <p:spPr>
           <a:xfrm>
-            <a:off x="6319174" y="836712"/>
-            <a:ext cx="1656184" cy="360040"/>
+            <a:off x="4739381" y="1115616"/>
+            <a:ext cx="1242138" cy="480053"/>
           </a:xfrm>
           <a:prstGeom prst="rect">
             <a:avLst/>
@@ -6018,8 +6020,8 @@
         </p:nvSpPr>
         <p:spPr>
           <a:xfrm>
-            <a:off x="4987026" y="1340768"/>
-            <a:ext cx="936104" cy="360040"/>
+            <a:off x="3740270" y="1787691"/>
+            <a:ext cx="702078" cy="480053"/>
           </a:xfrm>
           <a:prstGeom prst="rect">
             <a:avLst/>
@@ -6073,8 +6075,8 @@
         </p:nvSpPr>
         <p:spPr>
           <a:xfrm>
-            <a:off x="6319174" y="1340768"/>
-            <a:ext cx="1656184" cy="360040"/>
+            <a:off x="4739381" y="1787691"/>
+            <a:ext cx="1242138" cy="480053"/>
           </a:xfrm>
           <a:prstGeom prst="rect">
             <a:avLst/>
@@ -6117,8 +6119,8 @@
         </p:nvSpPr>
         <p:spPr>
           <a:xfrm>
-            <a:off x="4987026" y="1844824"/>
-            <a:ext cx="936104" cy="360040"/>
+            <a:off x="3740270" y="2459766"/>
+            <a:ext cx="702078" cy="480053"/>
           </a:xfrm>
           <a:prstGeom prst="rect">
             <a:avLst/>
@@ -6172,8 +6174,8 @@
         </p:nvSpPr>
         <p:spPr>
           <a:xfrm>
-            <a:off x="6319174" y="1844824"/>
-            <a:ext cx="1656184" cy="360040"/>
+            <a:off x="4739381" y="2459766"/>
+            <a:ext cx="1242138" cy="480053"/>
           </a:xfrm>
           <a:prstGeom prst="rect">
             <a:avLst/>
@@ -6216,8 +6218,8 @@
         </p:nvSpPr>
         <p:spPr>
           <a:xfrm>
-            <a:off x="5003546" y="2380940"/>
-            <a:ext cx="936104" cy="360040"/>
+            <a:off x="3752660" y="3174587"/>
+            <a:ext cx="702078" cy="480053"/>
           </a:xfrm>
           <a:prstGeom prst="rect">
             <a:avLst/>
@@ -6287,8 +6289,8 @@
         </p:nvSpPr>
         <p:spPr>
           <a:xfrm>
-            <a:off x="6335694" y="2374280"/>
-            <a:ext cx="684578" cy="334640"/>
+            <a:off x="4751770" y="3165707"/>
+            <a:ext cx="513434" cy="446187"/>
           </a:xfrm>
           <a:prstGeom prst="rect">
             <a:avLst/>
@@ -6331,8 +6333,8 @@
         </p:nvSpPr>
         <p:spPr>
           <a:xfrm>
-            <a:off x="5051618" y="3587328"/>
-            <a:ext cx="2988332" cy="2016224"/>
+            <a:off x="3788714" y="4783104"/>
+            <a:ext cx="2241249" cy="2688299"/>
           </a:xfrm>
           <a:prstGeom prst="rect">
             <a:avLst/>
@@ -6375,8 +6377,8 @@
         </p:nvSpPr>
         <p:spPr>
           <a:xfrm>
-            <a:off x="5051618" y="3212976"/>
-            <a:ext cx="936104" cy="360040"/>
+            <a:off x="3788714" y="4283968"/>
+            <a:ext cx="702078" cy="480053"/>
           </a:xfrm>
           <a:prstGeom prst="rect">
             <a:avLst/>
@@ -6438,8 +6440,8 @@
         </p:nvSpPr>
         <p:spPr>
           <a:xfrm>
-            <a:off x="611560" y="620688"/>
-            <a:ext cx="7848872" cy="6120680"/>
+            <a:off x="458670" y="827584"/>
+            <a:ext cx="5886654" cy="8160907"/>
           </a:xfrm>
           <a:prstGeom prst="rect">
             <a:avLst/>
@@ -6479,8 +6481,8 @@
         </p:nvSpPr>
         <p:spPr>
           <a:xfrm>
-            <a:off x="611560" y="116632"/>
-            <a:ext cx="3024336" cy="369332"/>
+            <a:off x="458670" y="155509"/>
+            <a:ext cx="2268252" cy="369332"/>
           </a:xfrm>
           <a:prstGeom prst="rect">
             <a:avLst/>
@@ -6509,8 +6511,8 @@
         </p:nvSpPr>
         <p:spPr>
           <a:xfrm>
-            <a:off x="5939650" y="116632"/>
-            <a:ext cx="900100" cy="369332"/>
+            <a:off x="4454738" y="155509"/>
+            <a:ext cx="675075" cy="492443"/>
           </a:xfrm>
           <a:prstGeom prst="roundRect">
             <a:avLst/>
@@ -6556,8 +6558,8 @@
         </p:nvSpPr>
         <p:spPr>
           <a:xfrm>
-            <a:off x="6917910" y="116632"/>
-            <a:ext cx="900100" cy="369332"/>
+            <a:off x="5188433" y="155509"/>
+            <a:ext cx="675075" cy="492443"/>
           </a:xfrm>
           <a:prstGeom prst="roundRect">
             <a:avLst/>
@@ -6600,8 +6602,8 @@
         </p:nvSpPr>
         <p:spPr>
           <a:xfrm>
-            <a:off x="4355976" y="116632"/>
-            <a:ext cx="1404156" cy="369332"/>
+            <a:off x="3266982" y="155509"/>
+            <a:ext cx="1053117" cy="492443"/>
           </a:xfrm>
           <a:prstGeom prst="roundRect">
             <a:avLst/>
@@ -6644,8 +6646,8 @@
         </p:nvSpPr>
         <p:spPr>
           <a:xfrm>
-            <a:off x="2430742" y="2348880"/>
-            <a:ext cx="1656184" cy="360040"/>
+            <a:off x="1823057" y="3131840"/>
+            <a:ext cx="1242138" cy="480053"/>
           </a:xfrm>
           <a:prstGeom prst="rect">
             <a:avLst/>
@@ -6688,8 +6690,8 @@
         </p:nvSpPr>
         <p:spPr>
           <a:xfrm>
-            <a:off x="7290780" y="2374280"/>
-            <a:ext cx="684578" cy="334640"/>
+            <a:off x="5468085" y="3165707"/>
+            <a:ext cx="513434" cy="446187"/>
           </a:xfrm>
           <a:prstGeom prst="rect">
             <a:avLst/>
@@ -6732,8 +6734,8 @@
         </p:nvSpPr>
         <p:spPr>
           <a:xfrm>
-            <a:off x="1098594" y="2888940"/>
-            <a:ext cx="1332148" cy="360040"/>
+            <a:off x="823946" y="3851920"/>
+            <a:ext cx="999111" cy="480053"/>
           </a:xfrm>
           <a:prstGeom prst="rect">
             <a:avLst/>
@@ -6803,8 +6805,8 @@
         </p:nvSpPr>
         <p:spPr>
           <a:xfrm>
-            <a:off x="2430742" y="2888940"/>
-            <a:ext cx="701098" cy="360040"/>
+            <a:off x="1823056" y="3851920"/>
+            <a:ext cx="525824" cy="480053"/>
           </a:xfrm>
           <a:prstGeom prst="rect">
             <a:avLst/>
@@ -6847,8 +6849,8 @@
         </p:nvSpPr>
         <p:spPr>
           <a:xfrm>
-            <a:off x="3314700" y="2888940"/>
-            <a:ext cx="772226" cy="360040"/>
+            <a:off x="2486025" y="3851920"/>
+            <a:ext cx="579170" cy="480053"/>
           </a:xfrm>
           <a:prstGeom prst="rect">
             <a:avLst/>
@@ -6921,8 +6923,8 @@
         </p:nvSpPr>
         <p:spPr>
           <a:xfrm>
-            <a:off x="611560" y="1196752"/>
-            <a:ext cx="1962218" cy="6192688"/>
+            <a:off x="458670" y="1595670"/>
+            <a:ext cx="1471664" cy="8256917"/>
           </a:xfrm>
           <a:prstGeom prst="rect">
             <a:avLst/>
@@ -6962,8 +6964,8 @@
         </p:nvSpPr>
         <p:spPr>
           <a:xfrm>
-            <a:off x="611560" y="116632"/>
-            <a:ext cx="3024336" cy="369332"/>
+            <a:off x="458670" y="155509"/>
+            <a:ext cx="2268252" cy="369332"/>
           </a:xfrm>
           <a:prstGeom prst="rect">
             <a:avLst/>
@@ -6992,8 +6994,8 @@
         </p:nvSpPr>
         <p:spPr>
           <a:xfrm>
-            <a:off x="611560" y="620688"/>
-            <a:ext cx="7848872" cy="576064"/>
+            <a:off x="458670" y="827584"/>
+            <a:ext cx="5886654" cy="768085"/>
           </a:xfrm>
           <a:prstGeom prst="rect">
             <a:avLst/>
@@ -7033,8 +7035,8 @@
         </p:nvSpPr>
         <p:spPr>
           <a:xfrm>
-            <a:off x="2573778" y="1196752"/>
-            <a:ext cx="5886654" cy="6192688"/>
+            <a:off x="1930333" y="1595670"/>
+            <a:ext cx="4414991" cy="8256917"/>
           </a:xfrm>
           <a:prstGeom prst="rect">
             <a:avLst/>
@@ -7074,8 +7076,8 @@
         </p:nvSpPr>
         <p:spPr>
           <a:xfrm>
-            <a:off x="3023828" y="724054"/>
-            <a:ext cx="3024336" cy="369332"/>
+            <a:off x="2267871" y="965405"/>
+            <a:ext cx="2268252" cy="646331"/>
           </a:xfrm>
           <a:prstGeom prst="rect">
             <a:avLst/>
@@ -7105,8 +7107,8 @@
         </p:nvSpPr>
         <p:spPr>
           <a:xfrm>
-            <a:off x="80501" y="3256948"/>
-            <a:ext cx="3024336" cy="646331"/>
+            <a:off x="60376" y="4342598"/>
+            <a:ext cx="2268252" cy="646331"/>
           </a:xfrm>
           <a:prstGeom prst="rect">
             <a:avLst/>
@@ -7144,8 +7146,8 @@
         </p:nvSpPr>
         <p:spPr>
           <a:xfrm>
-            <a:off x="2573778" y="2924944"/>
-            <a:ext cx="5886654" cy="4464496"/>
+            <a:off x="1930333" y="3899926"/>
+            <a:ext cx="4414991" cy="5952661"/>
           </a:xfrm>
           <a:prstGeom prst="rect">
             <a:avLst/>
@@ -7192,8 +7194,8 @@
           </p:nvPr>
         </p:nvGraphicFramePr>
         <p:xfrm>
-          <a:off x="2735796" y="1700808"/>
-          <a:ext cx="5400600" cy="1112520"/>
+          <a:off x="2051847" y="2267744"/>
+          <a:ext cx="4050450" cy="1483359"/>
         </p:xfrm>
         <a:graphic>
           <a:graphicData uri="http://schemas.openxmlformats.org/drawingml/2006/table">
@@ -7202,28 +7204,28 @@
                 <a:tableStyleId>{5C22544A-7EE6-4342-B048-85BDC9FD1C3A}</a:tableStyleId>
               </a:tblPr>
               <a:tblGrid>
-                <a:gridCol w="540060"/>
-                <a:gridCol w="540060"/>
-                <a:gridCol w="540060"/>
-                <a:gridCol w="540060"/>
-                <a:gridCol w="540060"/>
-                <a:gridCol w="540060"/>
-                <a:gridCol w="540060"/>
-                <a:gridCol w="540060"/>
-                <a:gridCol w="540060"/>
-                <a:gridCol w="540060"/>
+                <a:gridCol w="405045"/>
+                <a:gridCol w="405045"/>
+                <a:gridCol w="405045"/>
+                <a:gridCol w="405045"/>
+                <a:gridCol w="405045"/>
+                <a:gridCol w="405045"/>
+                <a:gridCol w="405045"/>
+                <a:gridCol w="405045"/>
+                <a:gridCol w="405045"/>
+                <a:gridCol w="405045"/>
               </a:tblGrid>
-              <a:tr h="370840">
+              <a:tr h="494453">
                 <a:tc>
                   <a:txBody>
                     <a:bodyPr/>
                     <a:lstStyle/>
                     <a:p>
                       <a:pPr latinLnBrk="1"/>
-                      <a:endParaRPr lang="ko-KR" altLang="en-US" dirty="0"/>
+                      <a:endParaRPr lang="ko-KR" altLang="en-US" sz="2400" dirty="0"/>
                     </a:p>
                   </a:txBody>
-                  <a:tcPr/>
+                  <a:tcPr marL="68580" marR="68580" marT="60960" marB="60960"/>
                 </a:tc>
                 <a:tc>
                   <a:txBody>
@@ -7231,10 +7233,10 @@
                     <a:lstStyle/>
                     <a:p>
                       <a:pPr latinLnBrk="1"/>
-                      <a:endParaRPr lang="ko-KR" altLang="en-US"/>
+                      <a:endParaRPr lang="ko-KR" altLang="en-US" sz="2400"/>
                     </a:p>
                   </a:txBody>
-                  <a:tcPr/>
+                  <a:tcPr marL="68580" marR="68580" marT="60960" marB="60960"/>
                 </a:tc>
                 <a:tc>
                   <a:txBody>
@@ -7242,10 +7244,10 @@
                     <a:lstStyle/>
                     <a:p>
                       <a:pPr latinLnBrk="1"/>
-                      <a:endParaRPr lang="ko-KR" altLang="en-US"/>
+                      <a:endParaRPr lang="ko-KR" altLang="en-US" sz="2400"/>
                     </a:p>
                   </a:txBody>
-                  <a:tcPr/>
+                  <a:tcPr marL="68580" marR="68580" marT="60960" marB="60960"/>
                 </a:tc>
                 <a:tc>
                   <a:txBody>
@@ -7253,10 +7255,10 @@
                     <a:lstStyle/>
                     <a:p>
                       <a:pPr latinLnBrk="1"/>
-                      <a:endParaRPr lang="ko-KR" altLang="en-US"/>
+                      <a:endParaRPr lang="ko-KR" altLang="en-US" sz="2400"/>
                     </a:p>
                   </a:txBody>
-                  <a:tcPr/>
+                  <a:tcPr marL="68580" marR="68580" marT="60960" marB="60960"/>
                 </a:tc>
                 <a:tc>
                   <a:txBody>
@@ -7264,10 +7266,10 @@
                     <a:lstStyle/>
                     <a:p>
                       <a:pPr latinLnBrk="1"/>
-                      <a:endParaRPr lang="ko-KR" altLang="en-US"/>
+                      <a:endParaRPr lang="ko-KR" altLang="en-US" sz="2400"/>
                     </a:p>
                   </a:txBody>
-                  <a:tcPr/>
+                  <a:tcPr marL="68580" marR="68580" marT="60960" marB="60960"/>
                 </a:tc>
                 <a:tc>
                   <a:txBody>
@@ -7275,10 +7277,10 @@
                     <a:lstStyle/>
                     <a:p>
                       <a:pPr latinLnBrk="1"/>
-                      <a:endParaRPr lang="ko-KR" altLang="en-US"/>
+                      <a:endParaRPr lang="ko-KR" altLang="en-US" sz="2400"/>
                     </a:p>
                   </a:txBody>
-                  <a:tcPr/>
+                  <a:tcPr marL="68580" marR="68580" marT="60960" marB="60960"/>
                 </a:tc>
                 <a:tc>
                   <a:txBody>
@@ -7286,10 +7288,10 @@
                     <a:lstStyle/>
                     <a:p>
                       <a:pPr latinLnBrk="1"/>
-                      <a:endParaRPr lang="ko-KR" altLang="en-US"/>
+                      <a:endParaRPr lang="ko-KR" altLang="en-US" sz="2400"/>
                     </a:p>
                   </a:txBody>
-                  <a:tcPr/>
+                  <a:tcPr marL="68580" marR="68580" marT="60960" marB="60960"/>
                 </a:tc>
                 <a:tc>
                   <a:txBody>
@@ -7297,10 +7299,10 @@
                     <a:lstStyle/>
                     <a:p>
                       <a:pPr latinLnBrk="1"/>
-                      <a:endParaRPr lang="ko-KR" altLang="en-US"/>
+                      <a:endParaRPr lang="ko-KR" altLang="en-US" sz="2400"/>
                     </a:p>
                   </a:txBody>
-                  <a:tcPr/>
+                  <a:tcPr marL="68580" marR="68580" marT="60960" marB="60960"/>
                 </a:tc>
                 <a:tc>
                   <a:txBody>
@@ -7308,10 +7310,10 @@
                     <a:lstStyle/>
                     <a:p>
                       <a:pPr latinLnBrk="1"/>
-                      <a:endParaRPr lang="ko-KR" altLang="en-US"/>
+                      <a:endParaRPr lang="ko-KR" altLang="en-US" sz="2400"/>
                     </a:p>
                   </a:txBody>
-                  <a:tcPr/>
+                  <a:tcPr marL="68580" marR="68580" marT="60960" marB="60960"/>
                 </a:tc>
                 <a:tc>
                   <a:txBody>
@@ -7319,23 +7321,23 @@
                     <a:lstStyle/>
                     <a:p>
                       <a:pPr latinLnBrk="1"/>
-                      <a:endParaRPr lang="ko-KR" altLang="en-US"/>
+                      <a:endParaRPr lang="ko-KR" altLang="en-US" sz="2400"/>
                     </a:p>
                   </a:txBody>
-                  <a:tcPr/>
+                  <a:tcPr marL="68580" marR="68580" marT="60960" marB="60960"/>
                 </a:tc>
               </a:tr>
-              <a:tr h="370840">
+              <a:tr h="494453">
                 <a:tc>
                   <a:txBody>
                     <a:bodyPr/>
                     <a:lstStyle/>
                     <a:p>
                       <a:pPr latinLnBrk="1"/>
-                      <a:endParaRPr lang="ko-KR" altLang="en-US"/>
+                      <a:endParaRPr lang="ko-KR" altLang="en-US" sz="2400"/>
                     </a:p>
                   </a:txBody>
-                  <a:tcPr/>
+                  <a:tcPr marL="68580" marR="68580" marT="60960" marB="60960"/>
                 </a:tc>
                 <a:tc>
                   <a:txBody>
@@ -7343,10 +7345,10 @@
                     <a:lstStyle/>
                     <a:p>
                       <a:pPr latinLnBrk="1"/>
-                      <a:endParaRPr lang="ko-KR" altLang="en-US" dirty="0"/>
+                      <a:endParaRPr lang="ko-KR" altLang="en-US" sz="2400" dirty="0"/>
                     </a:p>
                   </a:txBody>
-                  <a:tcPr/>
+                  <a:tcPr marL="68580" marR="68580" marT="60960" marB="60960"/>
                 </a:tc>
                 <a:tc>
                   <a:txBody>
@@ -7354,10 +7356,10 @@
                     <a:lstStyle/>
                     <a:p>
                       <a:pPr latinLnBrk="1"/>
-                      <a:endParaRPr lang="ko-KR" altLang="en-US"/>
+                      <a:endParaRPr lang="ko-KR" altLang="en-US" sz="2400"/>
                     </a:p>
                   </a:txBody>
-                  <a:tcPr/>
+                  <a:tcPr marL="68580" marR="68580" marT="60960" marB="60960"/>
                 </a:tc>
                 <a:tc>
                   <a:txBody>
@@ -7365,10 +7367,10 @@
                     <a:lstStyle/>
                     <a:p>
                       <a:pPr latinLnBrk="1"/>
-                      <a:endParaRPr lang="ko-KR" altLang="en-US"/>
+                      <a:endParaRPr lang="ko-KR" altLang="en-US" sz="2400"/>
                     </a:p>
                   </a:txBody>
-                  <a:tcPr/>
+                  <a:tcPr marL="68580" marR="68580" marT="60960" marB="60960"/>
                 </a:tc>
                 <a:tc>
                   <a:txBody>
@@ -7376,10 +7378,10 @@
                     <a:lstStyle/>
                     <a:p>
                       <a:pPr latinLnBrk="1"/>
-                      <a:endParaRPr lang="ko-KR" altLang="en-US" dirty="0"/>
+                      <a:endParaRPr lang="ko-KR" altLang="en-US" sz="2400" dirty="0"/>
                     </a:p>
                   </a:txBody>
-                  <a:tcPr/>
+                  <a:tcPr marL="68580" marR="68580" marT="60960" marB="60960"/>
                 </a:tc>
                 <a:tc>
                   <a:txBody>
@@ -7387,10 +7389,10 @@
                     <a:lstStyle/>
                     <a:p>
                       <a:pPr latinLnBrk="1"/>
-                      <a:endParaRPr lang="ko-KR" altLang="en-US"/>
+                      <a:endParaRPr lang="ko-KR" altLang="en-US" sz="2400"/>
                     </a:p>
                   </a:txBody>
-                  <a:tcPr/>
+                  <a:tcPr marL="68580" marR="68580" marT="60960" marB="60960"/>
                 </a:tc>
                 <a:tc>
                   <a:txBody>
@@ -7398,10 +7400,10 @@
                     <a:lstStyle/>
                     <a:p>
                       <a:pPr latinLnBrk="1"/>
-                      <a:endParaRPr lang="ko-KR" altLang="en-US"/>
+                      <a:endParaRPr lang="ko-KR" altLang="en-US" sz="2400"/>
                     </a:p>
                   </a:txBody>
-                  <a:tcPr/>
+                  <a:tcPr marL="68580" marR="68580" marT="60960" marB="60960"/>
                 </a:tc>
                 <a:tc>
                   <a:txBody>
@@ -7409,10 +7411,10 @@
                     <a:lstStyle/>
                     <a:p>
                       <a:pPr latinLnBrk="1"/>
-                      <a:endParaRPr lang="ko-KR" altLang="en-US"/>
+                      <a:endParaRPr lang="ko-KR" altLang="en-US" sz="2400"/>
                     </a:p>
                   </a:txBody>
-                  <a:tcPr/>
+                  <a:tcPr marL="68580" marR="68580" marT="60960" marB="60960"/>
                 </a:tc>
                 <a:tc>
                   <a:txBody>
@@ -7420,10 +7422,10 @@
                     <a:lstStyle/>
                     <a:p>
                       <a:pPr latinLnBrk="1"/>
-                      <a:endParaRPr lang="ko-KR" altLang="en-US"/>
+                      <a:endParaRPr lang="ko-KR" altLang="en-US" sz="2400"/>
                     </a:p>
                   </a:txBody>
-                  <a:tcPr/>
+                  <a:tcPr marL="68580" marR="68580" marT="60960" marB="60960"/>
                 </a:tc>
                 <a:tc>
                   <a:txBody>
@@ -7431,23 +7433,23 @@
                     <a:lstStyle/>
                     <a:p>
                       <a:pPr latinLnBrk="1"/>
-                      <a:endParaRPr lang="ko-KR" altLang="en-US" dirty="0"/>
+                      <a:endParaRPr lang="ko-KR" altLang="en-US" sz="2400" dirty="0"/>
                     </a:p>
                   </a:txBody>
-                  <a:tcPr/>
+                  <a:tcPr marL="68580" marR="68580" marT="60960" marB="60960"/>
                 </a:tc>
               </a:tr>
-              <a:tr h="370840">
+              <a:tr h="494453">
                 <a:tc>
                   <a:txBody>
                     <a:bodyPr/>
                     <a:lstStyle/>
                     <a:p>
                       <a:pPr latinLnBrk="1"/>
-                      <a:endParaRPr lang="ko-KR" altLang="en-US"/>
+                      <a:endParaRPr lang="ko-KR" altLang="en-US" sz="2400"/>
                     </a:p>
                   </a:txBody>
-                  <a:tcPr/>
+                  <a:tcPr marL="68580" marR="68580" marT="60960" marB="60960"/>
                 </a:tc>
                 <a:tc>
                   <a:txBody>
@@ -7455,10 +7457,10 @@
                     <a:lstStyle/>
                     <a:p>
                       <a:pPr latinLnBrk="1"/>
-                      <a:endParaRPr lang="ko-KR" altLang="en-US"/>
+                      <a:endParaRPr lang="ko-KR" altLang="en-US" sz="2400"/>
                     </a:p>
                   </a:txBody>
-                  <a:tcPr/>
+                  <a:tcPr marL="68580" marR="68580" marT="60960" marB="60960"/>
                 </a:tc>
                 <a:tc>
                   <a:txBody>
@@ -7466,10 +7468,10 @@
                     <a:lstStyle/>
                     <a:p>
                       <a:pPr latinLnBrk="1"/>
-                      <a:endParaRPr lang="ko-KR" altLang="en-US"/>
+                      <a:endParaRPr lang="ko-KR" altLang="en-US" sz="2400"/>
                     </a:p>
                   </a:txBody>
-                  <a:tcPr/>
+                  <a:tcPr marL="68580" marR="68580" marT="60960" marB="60960"/>
                 </a:tc>
                 <a:tc>
                   <a:txBody>
@@ -7477,10 +7479,10 @@
                     <a:lstStyle/>
                     <a:p>
                       <a:pPr latinLnBrk="1"/>
-                      <a:endParaRPr lang="ko-KR" altLang="en-US"/>
+                      <a:endParaRPr lang="ko-KR" altLang="en-US" sz="2400"/>
                     </a:p>
                   </a:txBody>
-                  <a:tcPr/>
+                  <a:tcPr marL="68580" marR="68580" marT="60960" marB="60960"/>
                 </a:tc>
                 <a:tc>
                   <a:txBody>
@@ -7488,10 +7490,10 @@
                     <a:lstStyle/>
                     <a:p>
                       <a:pPr latinLnBrk="1"/>
-                      <a:endParaRPr lang="ko-KR" altLang="en-US"/>
+                      <a:endParaRPr lang="ko-KR" altLang="en-US" sz="2400"/>
                     </a:p>
                   </a:txBody>
-                  <a:tcPr/>
+                  <a:tcPr marL="68580" marR="68580" marT="60960" marB="60960"/>
                 </a:tc>
                 <a:tc>
                   <a:txBody>
@@ -7499,10 +7501,10 @@
                     <a:lstStyle/>
                     <a:p>
                       <a:pPr latinLnBrk="1"/>
-                      <a:endParaRPr lang="ko-KR" altLang="en-US"/>
+                      <a:endParaRPr lang="ko-KR" altLang="en-US" sz="2400"/>
                     </a:p>
                   </a:txBody>
-                  <a:tcPr/>
+                  <a:tcPr marL="68580" marR="68580" marT="60960" marB="60960"/>
                 </a:tc>
                 <a:tc>
                   <a:txBody>
@@ -7510,10 +7512,10 @@
                     <a:lstStyle/>
                     <a:p>
                       <a:pPr latinLnBrk="1"/>
-                      <a:endParaRPr lang="ko-KR" altLang="en-US"/>
+                      <a:endParaRPr lang="ko-KR" altLang="en-US" sz="2400"/>
                     </a:p>
                   </a:txBody>
-                  <a:tcPr/>
+                  <a:tcPr marL="68580" marR="68580" marT="60960" marB="60960"/>
                 </a:tc>
                 <a:tc>
                   <a:txBody>
@@ -7521,10 +7523,10 @@
                     <a:lstStyle/>
                     <a:p>
                       <a:pPr latinLnBrk="1"/>
-                      <a:endParaRPr lang="ko-KR" altLang="en-US"/>
+                      <a:endParaRPr lang="ko-KR" altLang="en-US" sz="2400"/>
                     </a:p>
                   </a:txBody>
-                  <a:tcPr/>
+                  <a:tcPr marL="68580" marR="68580" marT="60960" marB="60960"/>
                 </a:tc>
                 <a:tc>
                   <a:txBody>
@@ -7532,10 +7534,10 @@
                     <a:lstStyle/>
                     <a:p>
                       <a:pPr latinLnBrk="1"/>
-                      <a:endParaRPr lang="ko-KR" altLang="en-US"/>
+                      <a:endParaRPr lang="ko-KR" altLang="en-US" sz="2400"/>
                     </a:p>
                   </a:txBody>
-                  <a:tcPr/>
+                  <a:tcPr marL="68580" marR="68580" marT="60960" marB="60960"/>
                 </a:tc>
                 <a:tc>
                   <a:txBody>
@@ -7543,10 +7545,10 @@
                     <a:lstStyle/>
                     <a:p>
                       <a:pPr latinLnBrk="1"/>
-                      <a:endParaRPr lang="ko-KR" altLang="en-US" dirty="0"/>
+                      <a:endParaRPr lang="ko-KR" altLang="en-US" sz="2400" dirty="0"/>
                     </a:p>
                   </a:txBody>
-                  <a:tcPr/>
+                  <a:tcPr marL="68580" marR="68580" marT="60960" marB="60960"/>
                 </a:tc>
               </a:tr>
             </a:tbl>
@@ -7561,8 +7563,8 @@
         </p:nvSpPr>
         <p:spPr>
           <a:xfrm>
-            <a:off x="7202813" y="3072282"/>
-            <a:ext cx="864096" cy="360040"/>
+            <a:off x="5402110" y="4096376"/>
+            <a:ext cx="648072" cy="480053"/>
           </a:xfrm>
           <a:prstGeom prst="roundRect">
             <a:avLst/>
@@ -7605,8 +7607,8 @@
         </p:nvSpPr>
         <p:spPr>
           <a:xfrm>
-            <a:off x="6804248" y="1268760"/>
-            <a:ext cx="1362472" cy="360040"/>
+            <a:off x="5103186" y="1691680"/>
+            <a:ext cx="1021854" cy="480053"/>
           </a:xfrm>
           <a:prstGeom prst="roundRect">
             <a:avLst/>
@@ -7653,8 +7655,8 @@
         </p:nvSpPr>
         <p:spPr>
           <a:xfrm>
-            <a:off x="2573778" y="3623568"/>
-            <a:ext cx="5886654" cy="3765872"/>
+            <a:off x="1930333" y="4831424"/>
+            <a:ext cx="4414991" cy="5021163"/>
           </a:xfrm>
           <a:prstGeom prst="rect">
             <a:avLst/>
@@ -7694,8 +7696,8 @@
         </p:nvSpPr>
         <p:spPr>
           <a:xfrm>
-            <a:off x="2573778" y="3623568"/>
-            <a:ext cx="2142238" cy="3765872"/>
+            <a:off x="1930333" y="4831424"/>
+            <a:ext cx="1606679" cy="5021163"/>
           </a:xfrm>
           <a:prstGeom prst="rect">
             <a:avLst/>
@@ -7735,8 +7737,8 @@
         </p:nvSpPr>
         <p:spPr>
           <a:xfrm>
-            <a:off x="3023828" y="3072282"/>
-            <a:ext cx="2412268" cy="369332"/>
+            <a:off x="2267871" y="4096376"/>
+            <a:ext cx="1809201" cy="646331"/>
           </a:xfrm>
           <a:prstGeom prst="rect">
             <a:avLst/>
@@ -7766,8 +7768,8 @@
         </p:nvSpPr>
         <p:spPr>
           <a:xfrm>
-            <a:off x="5045094" y="3819500"/>
-            <a:ext cx="936104" cy="360040"/>
+            <a:off x="3783821" y="5092667"/>
+            <a:ext cx="702078" cy="480053"/>
           </a:xfrm>
           <a:prstGeom prst="rect">
             <a:avLst/>
@@ -7821,8 +7823,8 @@
         </p:nvSpPr>
         <p:spPr>
           <a:xfrm>
-            <a:off x="6377242" y="3819500"/>
-            <a:ext cx="1656184" cy="360040"/>
+            <a:off x="4782932" y="5092667"/>
+            <a:ext cx="1242138" cy="480053"/>
           </a:xfrm>
           <a:prstGeom prst="rect">
             <a:avLst/>
@@ -7865,8 +7867,8 @@
         </p:nvSpPr>
         <p:spPr>
           <a:xfrm>
-            <a:off x="5045094" y="4323556"/>
-            <a:ext cx="936104" cy="360040"/>
+            <a:off x="3783821" y="5764742"/>
+            <a:ext cx="702078" cy="480053"/>
           </a:xfrm>
           <a:prstGeom prst="rect">
             <a:avLst/>
@@ -7920,8 +7922,8 @@
         </p:nvSpPr>
         <p:spPr>
           <a:xfrm>
-            <a:off x="6377242" y="4323556"/>
-            <a:ext cx="1656184" cy="360040"/>
+            <a:off x="4782932" y="5764742"/>
+            <a:ext cx="1242138" cy="480053"/>
           </a:xfrm>
           <a:prstGeom prst="rect">
             <a:avLst/>
@@ -7964,8 +7966,8 @@
         </p:nvSpPr>
         <p:spPr>
           <a:xfrm>
-            <a:off x="5045094" y="4827612"/>
-            <a:ext cx="936104" cy="360040"/>
+            <a:off x="3783821" y="6436816"/>
+            <a:ext cx="702078" cy="480053"/>
           </a:xfrm>
           <a:prstGeom prst="rect">
             <a:avLst/>
@@ -8019,8 +8021,8 @@
         </p:nvSpPr>
         <p:spPr>
           <a:xfrm>
-            <a:off x="6377242" y="4827612"/>
-            <a:ext cx="1656184" cy="360040"/>
+            <a:off x="4782932" y="6436816"/>
+            <a:ext cx="1242138" cy="480053"/>
           </a:xfrm>
           <a:prstGeom prst="rect">
             <a:avLst/>
@@ -8063,8 +8065,8 @@
         </p:nvSpPr>
         <p:spPr>
           <a:xfrm>
-            <a:off x="5045094" y="5331668"/>
-            <a:ext cx="936104" cy="360040"/>
+            <a:off x="3783821" y="7108891"/>
+            <a:ext cx="702078" cy="480053"/>
           </a:xfrm>
           <a:prstGeom prst="rect">
             <a:avLst/>
@@ -8126,8 +8128,8 @@
         </p:nvSpPr>
         <p:spPr>
           <a:xfrm>
-            <a:off x="6377242" y="5331668"/>
-            <a:ext cx="360040" cy="360040"/>
+            <a:off x="4782932" y="7108891"/>
+            <a:ext cx="270030" cy="480053"/>
           </a:xfrm>
           <a:prstGeom prst="rect">
             <a:avLst/>
@@ -8170,8 +8172,8 @@
         </p:nvSpPr>
         <p:spPr>
           <a:xfrm>
-            <a:off x="5045094" y="5835724"/>
-            <a:ext cx="936104" cy="360040"/>
+            <a:off x="3783821" y="7780966"/>
+            <a:ext cx="702078" cy="480053"/>
           </a:xfrm>
           <a:prstGeom prst="rect">
             <a:avLst/>
@@ -8233,8 +8235,8 @@
         </p:nvSpPr>
         <p:spPr>
           <a:xfrm>
-            <a:off x="6377242" y="5835724"/>
-            <a:ext cx="360040" cy="360040"/>
+            <a:off x="4782932" y="7780966"/>
+            <a:ext cx="270030" cy="480053"/>
           </a:xfrm>
           <a:prstGeom prst="rect">
             <a:avLst/>
@@ -8277,8 +8279,8 @@
         </p:nvSpPr>
         <p:spPr>
           <a:xfrm>
-            <a:off x="5045094" y="6339780"/>
-            <a:ext cx="936104" cy="360040"/>
+            <a:off x="3783821" y="8453040"/>
+            <a:ext cx="702078" cy="480053"/>
           </a:xfrm>
           <a:prstGeom prst="rect">
             <a:avLst/>
@@ -8340,8 +8342,8 @@
         </p:nvSpPr>
         <p:spPr>
           <a:xfrm>
-            <a:off x="6377242" y="6339780"/>
-            <a:ext cx="360040" cy="360040"/>
+            <a:off x="4782932" y="8453040"/>
+            <a:ext cx="270030" cy="480053"/>
           </a:xfrm>
           <a:prstGeom prst="rect">
             <a:avLst/>
@@ -8384,8 +8386,8 @@
         </p:nvSpPr>
         <p:spPr>
           <a:xfrm>
-            <a:off x="6881298" y="5331668"/>
-            <a:ext cx="1152128" cy="360040"/>
+            <a:off x="5160974" y="7108891"/>
+            <a:ext cx="864096" cy="480053"/>
           </a:xfrm>
           <a:prstGeom prst="rect">
             <a:avLst/>
@@ -8428,8 +8430,8 @@
         </p:nvSpPr>
         <p:spPr>
           <a:xfrm>
-            <a:off x="6881298" y="5835724"/>
-            <a:ext cx="1152128" cy="360040"/>
+            <a:off x="5160974" y="7780966"/>
+            <a:ext cx="864096" cy="480053"/>
           </a:xfrm>
           <a:prstGeom prst="rect">
             <a:avLst/>
@@ -8472,8 +8474,8 @@
         </p:nvSpPr>
         <p:spPr>
           <a:xfrm>
-            <a:off x="6881298" y="6339780"/>
-            <a:ext cx="1152128" cy="360040"/>
+            <a:off x="5160974" y="8453040"/>
+            <a:ext cx="864096" cy="480053"/>
           </a:xfrm>
           <a:prstGeom prst="rect">
             <a:avLst/>
@@ -8516,8 +8518,8 @@
         </p:nvSpPr>
         <p:spPr>
           <a:xfrm>
-            <a:off x="5045094" y="6814368"/>
-            <a:ext cx="936104" cy="360040"/>
+            <a:off x="3783821" y="9085824"/>
+            <a:ext cx="702078" cy="480053"/>
           </a:xfrm>
           <a:prstGeom prst="rect">
             <a:avLst/>
@@ -8571,8 +8573,8 @@
         </p:nvSpPr>
         <p:spPr>
           <a:xfrm>
-            <a:off x="6372200" y="6814368"/>
-            <a:ext cx="1661226" cy="360040"/>
+            <a:off x="4779150" y="9085824"/>
+            <a:ext cx="1245920" cy="480053"/>
           </a:xfrm>
           <a:prstGeom prst="rect">
             <a:avLst/>
@@ -8615,8 +8617,8 @@
         </p:nvSpPr>
         <p:spPr>
           <a:xfrm>
-            <a:off x="2061090" y="3712710"/>
-            <a:ext cx="3024336" cy="369332"/>
+            <a:off x="1545818" y="4950280"/>
+            <a:ext cx="2268252" cy="369332"/>
           </a:xfrm>
           <a:prstGeom prst="rect">
             <a:avLst/>
@@ -8642,6 +8644,826 @@
     <p:extLst>
       <p:ext uri="{BB962C8B-B14F-4D97-AF65-F5344CB8AC3E}">
         <p14:creationId xmlns:p14="http://schemas.microsoft.com/office/powerpoint/2010/main" val="3665152312"/>
+      </p:ext>
+    </p:extLst>
+  </p:cSld>
+  <p:clrMapOvr>
+    <a:masterClrMapping/>
+  </p:clrMapOvr>
+</p:sld>
+</file>
+
+<file path=ppt/slides/slide6.xml><?xml version="1.0" encoding="utf-8"?>
+<p:sld xmlns:a="http://schemas.openxmlformats.org/drawingml/2006/main" xmlns:r="http://schemas.openxmlformats.org/officeDocument/2006/relationships" xmlns:p="http://schemas.openxmlformats.org/presentationml/2006/main">
+  <p:cSld>
+    <p:spTree>
+      <p:nvGrpSpPr>
+        <p:cNvPr id="1" name=""/>
+        <p:cNvGrpSpPr/>
+        <p:nvPr/>
+      </p:nvGrpSpPr>
+      <p:grpSpPr>
+        <a:xfrm>
+          <a:off x="0" y="0"/>
+          <a:ext cx="0" cy="0"/>
+          <a:chOff x="0" y="0"/>
+          <a:chExt cx="0" cy="0"/>
+        </a:xfrm>
+      </p:grpSpPr>
+      <p:pic>
+        <p:nvPicPr>
+          <p:cNvPr id="1026" name="Picture 2"/>
+          <p:cNvPicPr>
+            <a:picLocks noChangeAspect="1" noChangeArrowheads="1"/>
+          </p:cNvPicPr>
+          <p:nvPr/>
+        </p:nvPicPr>
+        <p:blipFill>
+          <a:blip r:embed="rId2">
+            <a:extLst>
+              <a:ext uri="{28A0092B-C50C-407E-A947-70E740481C1C}">
+                <a14:useLocalDpi xmlns:a14="http://schemas.microsoft.com/office/drawing/2010/main" val="0"/>
+              </a:ext>
+            </a:extLst>
+          </a:blip>
+          <a:srcRect/>
+          <a:stretch>
+            <a:fillRect/>
+          </a:stretch>
+        </p:blipFill>
+        <p:spPr bwMode="auto">
+          <a:xfrm>
+            <a:off x="701948" y="4945234"/>
+            <a:ext cx="5607372" cy="3724798"/>
+          </a:xfrm>
+          <a:prstGeom prst="rect">
+            <a:avLst/>
+          </a:prstGeom>
+          <a:noFill/>
+          <a:ln>
+            <a:noFill/>
+          </a:ln>
+          <a:effectLst/>
+          <a:extLst>
+            <a:ext uri="{909E8E84-426E-40DD-AFC4-6F175D3DCCD1}">
+              <a14:hiddenFill xmlns:a14="http://schemas.microsoft.com/office/drawing/2010/main">
+                <a:solidFill>
+                  <a:schemeClr val="accent1"/>
+                </a:solidFill>
+              </a14:hiddenFill>
+            </a:ext>
+            <a:ext uri="{91240B29-F687-4F45-9708-019B960494DF}">
+              <a14:hiddenLine xmlns:a14="http://schemas.microsoft.com/office/drawing/2010/main" w="9525">
+                <a:solidFill>
+                  <a:schemeClr val="tx1"/>
+                </a:solidFill>
+                <a:miter lim="800000"/>
+                <a:headEnd/>
+                <a:tailEnd/>
+              </a14:hiddenLine>
+            </a:ext>
+            <a:ext uri="{AF507438-7753-43E0-B8FC-AC1667EBCBE1}">
+              <a14:hiddenEffects xmlns:a14="http://schemas.microsoft.com/office/drawing/2010/main">
+                <a:effectLst>
+                  <a:outerShdw dist="35921" dir="2700000" algn="ctr" rotWithShape="0">
+                    <a:schemeClr val="bg2"/>
+                  </a:outerShdw>
+                </a:effectLst>
+              </a14:hiddenEffects>
+            </a:ext>
+          </a:extLst>
+        </p:spPr>
+      </p:pic>
+      <p:pic>
+        <p:nvPicPr>
+          <p:cNvPr id="1027" name="Picture 3"/>
+          <p:cNvPicPr>
+            <a:picLocks noChangeAspect="1" noChangeArrowheads="1"/>
+          </p:cNvPicPr>
+          <p:nvPr/>
+        </p:nvPicPr>
+        <p:blipFill>
+          <a:blip r:embed="rId3">
+            <a:extLst>
+              <a:ext uri="{28A0092B-C50C-407E-A947-70E740481C1C}">
+                <a14:useLocalDpi xmlns:a14="http://schemas.microsoft.com/office/drawing/2010/main" val="0"/>
+              </a:ext>
+            </a:extLst>
+          </a:blip>
+          <a:srcRect/>
+          <a:stretch>
+            <a:fillRect/>
+          </a:stretch>
+        </p:blipFill>
+        <p:spPr bwMode="auto">
+          <a:xfrm>
+            <a:off x="692696" y="323528"/>
+            <a:ext cx="5616624" cy="4276478"/>
+          </a:xfrm>
+          <a:prstGeom prst="rect">
+            <a:avLst/>
+          </a:prstGeom>
+          <a:noFill/>
+          <a:ln>
+            <a:noFill/>
+          </a:ln>
+          <a:effectLst/>
+          <a:extLst>
+            <a:ext uri="{909E8E84-426E-40DD-AFC4-6F175D3DCCD1}">
+              <a14:hiddenFill xmlns:a14="http://schemas.microsoft.com/office/drawing/2010/main">
+                <a:solidFill>
+                  <a:schemeClr val="accent1"/>
+                </a:solidFill>
+              </a14:hiddenFill>
+            </a:ext>
+            <a:ext uri="{91240B29-F687-4F45-9708-019B960494DF}">
+              <a14:hiddenLine xmlns:a14="http://schemas.microsoft.com/office/drawing/2010/main" w="9525">
+                <a:solidFill>
+                  <a:schemeClr val="tx1"/>
+                </a:solidFill>
+                <a:miter lim="800000"/>
+                <a:headEnd/>
+                <a:tailEnd/>
+              </a14:hiddenLine>
+            </a:ext>
+            <a:ext uri="{AF507438-7753-43E0-B8FC-AC1667EBCBE1}">
+              <a14:hiddenEffects xmlns:a14="http://schemas.microsoft.com/office/drawing/2010/main">
+                <a:effectLst>
+                  <a:outerShdw dist="35921" dir="2700000" algn="ctr" rotWithShape="0">
+                    <a:schemeClr val="bg2"/>
+                  </a:outerShdw>
+                </a:effectLst>
+              </a14:hiddenEffects>
+            </a:ext>
+          </a:extLst>
+        </p:spPr>
+      </p:pic>
+      <p:sp>
+        <p:nvSpPr>
+          <p:cNvPr id="4" name="직사각형 3"/>
+          <p:cNvSpPr/>
+          <p:nvPr/>
+        </p:nvSpPr>
+        <p:spPr>
+          <a:xfrm>
+            <a:off x="4437112" y="2267744"/>
+            <a:ext cx="1437908" cy="284956"/>
+          </a:xfrm>
+          <a:prstGeom prst="rect">
+            <a:avLst/>
+          </a:prstGeom>
+          <a:noFill/>
+          <a:ln w="38100">
+            <a:solidFill>
+              <a:srgbClr val="FF0000"/>
+            </a:solidFill>
+          </a:ln>
+        </p:spPr>
+        <p:style>
+          <a:lnRef idx="2">
+            <a:schemeClr val="accent1">
+              <a:shade val="50000"/>
+            </a:schemeClr>
+          </a:lnRef>
+          <a:fillRef idx="1">
+            <a:schemeClr val="accent1"/>
+          </a:fillRef>
+          <a:effectRef idx="0">
+            <a:schemeClr val="accent1"/>
+          </a:effectRef>
+          <a:fontRef idx="minor">
+            <a:schemeClr val="lt1"/>
+          </a:fontRef>
+        </p:style>
+        <p:txBody>
+          <a:bodyPr rtlCol="0" anchor="ctr"/>
+          <a:lstStyle/>
+          <a:p>
+            <a:pPr algn="ctr"/>
+            <a:endParaRPr lang="ko-KR" altLang="en-US"/>
+          </a:p>
+        </p:txBody>
+      </p:sp>
+      <p:sp>
+        <p:nvSpPr>
+          <p:cNvPr id="5" name="직사각형 4"/>
+          <p:cNvSpPr/>
+          <p:nvPr/>
+        </p:nvSpPr>
+        <p:spPr>
+          <a:xfrm>
+            <a:off x="5229200" y="2603500"/>
+            <a:ext cx="576064" cy="96292"/>
+          </a:xfrm>
+          <a:prstGeom prst="rect">
+            <a:avLst/>
+          </a:prstGeom>
+          <a:solidFill>
+            <a:schemeClr val="bg1"/>
+          </a:solidFill>
+          <a:ln>
+            <a:solidFill>
+              <a:schemeClr val="bg1"/>
+            </a:solidFill>
+          </a:ln>
+        </p:spPr>
+        <p:style>
+          <a:lnRef idx="2">
+            <a:schemeClr val="accent1">
+              <a:shade val="50000"/>
+            </a:schemeClr>
+          </a:lnRef>
+          <a:fillRef idx="1">
+            <a:schemeClr val="accent1"/>
+          </a:fillRef>
+          <a:effectRef idx="0">
+            <a:schemeClr val="accent1"/>
+          </a:effectRef>
+          <a:fontRef idx="minor">
+            <a:schemeClr val="lt1"/>
+          </a:fontRef>
+        </p:style>
+        <p:txBody>
+          <a:bodyPr rtlCol="0" anchor="ctr"/>
+          <a:lstStyle/>
+          <a:p>
+            <a:pPr algn="ctr"/>
+            <a:endParaRPr lang="ko-KR" altLang="en-US"/>
+          </a:p>
+        </p:txBody>
+      </p:sp>
+      <p:sp>
+        <p:nvSpPr>
+          <p:cNvPr id="8" name="직사각형 7"/>
+          <p:cNvSpPr/>
+          <p:nvPr/>
+        </p:nvSpPr>
+        <p:spPr>
+          <a:xfrm>
+            <a:off x="1556792" y="5292080"/>
+            <a:ext cx="1859508" cy="156220"/>
+          </a:xfrm>
+          <a:prstGeom prst="rect">
+            <a:avLst/>
+          </a:prstGeom>
+          <a:solidFill>
+            <a:schemeClr val="bg1"/>
+          </a:solidFill>
+          <a:ln>
+            <a:solidFill>
+              <a:schemeClr val="bg1"/>
+            </a:solidFill>
+          </a:ln>
+        </p:spPr>
+        <p:style>
+          <a:lnRef idx="2">
+            <a:schemeClr val="accent1">
+              <a:shade val="50000"/>
+            </a:schemeClr>
+          </a:lnRef>
+          <a:fillRef idx="1">
+            <a:schemeClr val="accent1"/>
+          </a:fillRef>
+          <a:effectRef idx="0">
+            <a:schemeClr val="accent1"/>
+          </a:effectRef>
+          <a:fontRef idx="minor">
+            <a:schemeClr val="lt1"/>
+          </a:fontRef>
+        </p:style>
+        <p:txBody>
+          <a:bodyPr rtlCol="0" anchor="ctr"/>
+          <a:lstStyle/>
+          <a:p>
+            <a:pPr algn="ctr"/>
+            <a:endParaRPr lang="ko-KR" altLang="en-US"/>
+          </a:p>
+        </p:txBody>
+      </p:sp>
+      <p:sp>
+        <p:nvSpPr>
+          <p:cNvPr id="9" name="직사각형 8"/>
+          <p:cNvSpPr/>
+          <p:nvPr/>
+        </p:nvSpPr>
+        <p:spPr>
+          <a:xfrm>
+            <a:off x="1785392" y="6390630"/>
+            <a:ext cx="1211560" cy="156220"/>
+          </a:xfrm>
+          <a:prstGeom prst="rect">
+            <a:avLst/>
+          </a:prstGeom>
+          <a:solidFill>
+            <a:schemeClr val="bg1"/>
+          </a:solidFill>
+          <a:ln>
+            <a:solidFill>
+              <a:schemeClr val="bg1"/>
+            </a:solidFill>
+          </a:ln>
+        </p:spPr>
+        <p:style>
+          <a:lnRef idx="2">
+            <a:schemeClr val="accent1">
+              <a:shade val="50000"/>
+            </a:schemeClr>
+          </a:lnRef>
+          <a:fillRef idx="1">
+            <a:schemeClr val="accent1"/>
+          </a:fillRef>
+          <a:effectRef idx="0">
+            <a:schemeClr val="accent1"/>
+          </a:effectRef>
+          <a:fontRef idx="minor">
+            <a:schemeClr val="lt1"/>
+          </a:fontRef>
+        </p:style>
+        <p:txBody>
+          <a:bodyPr rtlCol="0" anchor="ctr"/>
+          <a:lstStyle/>
+          <a:p>
+            <a:pPr algn="ctr"/>
+            <a:endParaRPr lang="ko-KR" altLang="en-US"/>
+          </a:p>
+        </p:txBody>
+      </p:sp>
+      <p:sp>
+        <p:nvSpPr>
+          <p:cNvPr id="10" name="직사각형 9"/>
+          <p:cNvSpPr/>
+          <p:nvPr/>
+        </p:nvSpPr>
+        <p:spPr>
+          <a:xfrm>
+            <a:off x="1550442" y="7781280"/>
+            <a:ext cx="1806550" cy="156220"/>
+          </a:xfrm>
+          <a:prstGeom prst="rect">
+            <a:avLst/>
+          </a:prstGeom>
+          <a:solidFill>
+            <a:schemeClr val="bg1"/>
+          </a:solidFill>
+          <a:ln>
+            <a:solidFill>
+              <a:schemeClr val="bg1"/>
+            </a:solidFill>
+          </a:ln>
+        </p:spPr>
+        <p:style>
+          <a:lnRef idx="2">
+            <a:schemeClr val="accent1">
+              <a:shade val="50000"/>
+            </a:schemeClr>
+          </a:lnRef>
+          <a:fillRef idx="1">
+            <a:schemeClr val="accent1"/>
+          </a:fillRef>
+          <a:effectRef idx="0">
+            <a:schemeClr val="accent1"/>
+          </a:effectRef>
+          <a:fontRef idx="minor">
+            <a:schemeClr val="lt1"/>
+          </a:fontRef>
+        </p:style>
+        <p:txBody>
+          <a:bodyPr rtlCol="0" anchor="ctr"/>
+          <a:lstStyle/>
+          <a:p>
+            <a:pPr algn="ctr"/>
+            <a:endParaRPr lang="ko-KR" altLang="en-US"/>
+          </a:p>
+        </p:txBody>
+      </p:sp>
+      <p:sp>
+        <p:nvSpPr>
+          <p:cNvPr id="11" name="직사각형 10"/>
+          <p:cNvSpPr/>
+          <p:nvPr/>
+        </p:nvSpPr>
+        <p:spPr>
+          <a:xfrm>
+            <a:off x="1183372" y="7228364"/>
+            <a:ext cx="637808" cy="193516"/>
+          </a:xfrm>
+          <a:prstGeom prst="rect">
+            <a:avLst/>
+          </a:prstGeom>
+          <a:noFill/>
+          <a:ln w="38100">
+            <a:solidFill>
+              <a:srgbClr val="FF0000"/>
+            </a:solidFill>
+          </a:ln>
+        </p:spPr>
+        <p:style>
+          <a:lnRef idx="2">
+            <a:schemeClr val="accent1">
+              <a:shade val="50000"/>
+            </a:schemeClr>
+          </a:lnRef>
+          <a:fillRef idx="1">
+            <a:schemeClr val="accent1"/>
+          </a:fillRef>
+          <a:effectRef idx="0">
+            <a:schemeClr val="accent1"/>
+          </a:effectRef>
+          <a:fontRef idx="minor">
+            <a:schemeClr val="lt1"/>
+          </a:fontRef>
+        </p:style>
+        <p:txBody>
+          <a:bodyPr rtlCol="0" anchor="ctr"/>
+          <a:lstStyle/>
+          <a:p>
+            <a:pPr algn="ctr"/>
+            <a:endParaRPr lang="ko-KR" altLang="en-US"/>
+          </a:p>
+        </p:txBody>
+      </p:sp>
+      <p:sp>
+        <p:nvSpPr>
+          <p:cNvPr id="12" name="직사각형 11"/>
+          <p:cNvSpPr/>
+          <p:nvPr/>
+        </p:nvSpPr>
+        <p:spPr>
+          <a:xfrm>
+            <a:off x="848092" y="5826284"/>
+            <a:ext cx="1110248" cy="185896"/>
+          </a:xfrm>
+          <a:prstGeom prst="rect">
+            <a:avLst/>
+          </a:prstGeom>
+          <a:noFill/>
+          <a:ln w="38100">
+            <a:solidFill>
+              <a:srgbClr val="FF0000"/>
+            </a:solidFill>
+          </a:ln>
+        </p:spPr>
+        <p:style>
+          <a:lnRef idx="2">
+            <a:schemeClr val="accent1">
+              <a:shade val="50000"/>
+            </a:schemeClr>
+          </a:lnRef>
+          <a:fillRef idx="1">
+            <a:schemeClr val="accent1"/>
+          </a:fillRef>
+          <a:effectRef idx="0">
+            <a:schemeClr val="accent1"/>
+          </a:effectRef>
+          <a:fontRef idx="minor">
+            <a:schemeClr val="lt1"/>
+          </a:fontRef>
+        </p:style>
+        <p:txBody>
+          <a:bodyPr rtlCol="0" anchor="ctr"/>
+          <a:lstStyle/>
+          <a:p>
+            <a:pPr algn="ctr"/>
+            <a:endParaRPr lang="ko-KR" altLang="en-US"/>
+          </a:p>
+        </p:txBody>
+      </p:sp>
+      <p:sp>
+        <p:nvSpPr>
+          <p:cNvPr id="13" name="직사각형 12"/>
+          <p:cNvSpPr/>
+          <p:nvPr/>
+        </p:nvSpPr>
+        <p:spPr>
+          <a:xfrm>
+            <a:off x="1168132" y="8478044"/>
+            <a:ext cx="691148" cy="193516"/>
+          </a:xfrm>
+          <a:prstGeom prst="rect">
+            <a:avLst/>
+          </a:prstGeom>
+          <a:noFill/>
+          <a:ln w="38100">
+            <a:solidFill>
+              <a:srgbClr val="FF0000"/>
+            </a:solidFill>
+          </a:ln>
+        </p:spPr>
+        <p:style>
+          <a:lnRef idx="2">
+            <a:schemeClr val="accent1">
+              <a:shade val="50000"/>
+            </a:schemeClr>
+          </a:lnRef>
+          <a:fillRef idx="1">
+            <a:schemeClr val="accent1"/>
+          </a:fillRef>
+          <a:effectRef idx="0">
+            <a:schemeClr val="accent1"/>
+          </a:effectRef>
+          <a:fontRef idx="minor">
+            <a:schemeClr val="lt1"/>
+          </a:fontRef>
+        </p:style>
+        <p:txBody>
+          <a:bodyPr rtlCol="0" anchor="ctr"/>
+          <a:lstStyle/>
+          <a:p>
+            <a:pPr algn="ctr"/>
+            <a:endParaRPr lang="ko-KR" altLang="en-US"/>
+          </a:p>
+        </p:txBody>
+      </p:sp>
+      <p:sp>
+        <p:nvSpPr>
+          <p:cNvPr id="14" name="직사각형 13"/>
+          <p:cNvSpPr/>
+          <p:nvPr/>
+        </p:nvSpPr>
+        <p:spPr>
+          <a:xfrm>
+            <a:off x="3270860" y="2230120"/>
+            <a:ext cx="576064" cy="96292"/>
+          </a:xfrm>
+          <a:prstGeom prst="rect">
+            <a:avLst/>
+          </a:prstGeom>
+          <a:solidFill>
+            <a:schemeClr val="bg1"/>
+          </a:solidFill>
+          <a:ln>
+            <a:solidFill>
+              <a:schemeClr val="bg1"/>
+            </a:solidFill>
+          </a:ln>
+        </p:spPr>
+        <p:style>
+          <a:lnRef idx="2">
+            <a:schemeClr val="accent1">
+              <a:shade val="50000"/>
+            </a:schemeClr>
+          </a:lnRef>
+          <a:fillRef idx="1">
+            <a:schemeClr val="accent1"/>
+          </a:fillRef>
+          <a:effectRef idx="0">
+            <a:schemeClr val="accent1"/>
+          </a:effectRef>
+          <a:fontRef idx="minor">
+            <a:schemeClr val="lt1"/>
+          </a:fontRef>
+        </p:style>
+        <p:txBody>
+          <a:bodyPr rtlCol="0" anchor="ctr"/>
+          <a:lstStyle/>
+          <a:p>
+            <a:pPr algn="ctr"/>
+            <a:endParaRPr lang="ko-KR" altLang="en-US"/>
+          </a:p>
+        </p:txBody>
+      </p:sp>
+      <p:sp>
+        <p:nvSpPr>
+          <p:cNvPr id="15" name="직사각형 14"/>
+          <p:cNvSpPr/>
+          <p:nvPr/>
+        </p:nvSpPr>
+        <p:spPr>
+          <a:xfrm>
+            <a:off x="3255620" y="2519680"/>
+            <a:ext cx="576064" cy="96292"/>
+          </a:xfrm>
+          <a:prstGeom prst="rect">
+            <a:avLst/>
+          </a:prstGeom>
+          <a:solidFill>
+            <a:schemeClr val="bg1"/>
+          </a:solidFill>
+          <a:ln>
+            <a:solidFill>
+              <a:schemeClr val="bg1"/>
+            </a:solidFill>
+          </a:ln>
+        </p:spPr>
+        <p:style>
+          <a:lnRef idx="2">
+            <a:schemeClr val="accent1">
+              <a:shade val="50000"/>
+            </a:schemeClr>
+          </a:lnRef>
+          <a:fillRef idx="1">
+            <a:schemeClr val="accent1"/>
+          </a:fillRef>
+          <a:effectRef idx="0">
+            <a:schemeClr val="accent1"/>
+          </a:effectRef>
+          <a:fontRef idx="minor">
+            <a:schemeClr val="lt1"/>
+          </a:fontRef>
+        </p:style>
+        <p:txBody>
+          <a:bodyPr rtlCol="0" anchor="ctr"/>
+          <a:lstStyle/>
+          <a:p>
+            <a:pPr algn="ctr"/>
+            <a:endParaRPr lang="ko-KR" altLang="en-US"/>
+          </a:p>
+        </p:txBody>
+      </p:sp>
+      <p:sp>
+        <p:nvSpPr>
+          <p:cNvPr id="16" name="직사각형 15"/>
+          <p:cNvSpPr/>
+          <p:nvPr/>
+        </p:nvSpPr>
+        <p:spPr>
+          <a:xfrm>
+            <a:off x="3255620" y="2786380"/>
+            <a:ext cx="798592" cy="201444"/>
+          </a:xfrm>
+          <a:prstGeom prst="rect">
+            <a:avLst/>
+          </a:prstGeom>
+          <a:solidFill>
+            <a:schemeClr val="bg1"/>
+          </a:solidFill>
+          <a:ln>
+            <a:solidFill>
+              <a:schemeClr val="bg1"/>
+            </a:solidFill>
+          </a:ln>
+        </p:spPr>
+        <p:style>
+          <a:lnRef idx="2">
+            <a:schemeClr val="accent1">
+              <a:shade val="50000"/>
+            </a:schemeClr>
+          </a:lnRef>
+          <a:fillRef idx="1">
+            <a:schemeClr val="accent1"/>
+          </a:fillRef>
+          <a:effectRef idx="0">
+            <a:schemeClr val="accent1"/>
+          </a:effectRef>
+          <a:fontRef idx="minor">
+            <a:schemeClr val="lt1"/>
+          </a:fontRef>
+        </p:style>
+        <p:txBody>
+          <a:bodyPr rtlCol="0" anchor="ctr"/>
+          <a:lstStyle/>
+          <a:p>
+            <a:pPr algn="ctr"/>
+            <a:endParaRPr lang="ko-KR" altLang="en-US"/>
+          </a:p>
+        </p:txBody>
+      </p:sp>
+    </p:spTree>
+    <p:extLst>
+      <p:ext uri="{BB962C8B-B14F-4D97-AF65-F5344CB8AC3E}">
+        <p14:creationId xmlns:p14="http://schemas.microsoft.com/office/powerpoint/2010/main" val="3552459928"/>
+      </p:ext>
+    </p:extLst>
+  </p:cSld>
+  <p:clrMapOvr>
+    <a:masterClrMapping/>
+  </p:clrMapOvr>
+</p:sld>
+</file>
+
+<file path=ppt/slides/slide7.xml><?xml version="1.0" encoding="utf-8"?>
+<p:sld xmlns:a="http://schemas.openxmlformats.org/drawingml/2006/main" xmlns:r="http://schemas.openxmlformats.org/officeDocument/2006/relationships" xmlns:p="http://schemas.openxmlformats.org/presentationml/2006/main">
+  <p:cSld>
+    <p:spTree>
+      <p:nvGrpSpPr>
+        <p:cNvPr id="1" name=""/>
+        <p:cNvGrpSpPr/>
+        <p:nvPr/>
+      </p:nvGrpSpPr>
+      <p:grpSpPr>
+        <a:xfrm>
+          <a:off x="0" y="0"/>
+          <a:ext cx="0" cy="0"/>
+          <a:chOff x="0" y="0"/>
+          <a:chExt cx="0" cy="0"/>
+        </a:xfrm>
+      </p:grpSpPr>
+      <p:pic>
+        <p:nvPicPr>
+          <p:cNvPr id="2050" name="Picture 2"/>
+          <p:cNvPicPr>
+            <a:picLocks noChangeAspect="1" noChangeArrowheads="1"/>
+          </p:cNvPicPr>
+          <p:nvPr/>
+        </p:nvPicPr>
+        <p:blipFill>
+          <a:blip r:embed="rId2">
+            <a:extLst>
+              <a:ext uri="{28A0092B-C50C-407E-A947-70E740481C1C}">
+                <a14:useLocalDpi xmlns:a14="http://schemas.microsoft.com/office/drawing/2010/main" val="0"/>
+              </a:ext>
+            </a:extLst>
+          </a:blip>
+          <a:srcRect/>
+          <a:stretch>
+            <a:fillRect/>
+          </a:stretch>
+        </p:blipFill>
+        <p:spPr bwMode="auto">
+          <a:xfrm>
+            <a:off x="1681163" y="3800475"/>
+            <a:ext cx="3495675" cy="2895600"/>
+          </a:xfrm>
+          <a:prstGeom prst="rect">
+            <a:avLst/>
+          </a:prstGeom>
+          <a:noFill/>
+          <a:ln>
+            <a:noFill/>
+          </a:ln>
+          <a:effectLst/>
+          <a:extLst>
+            <a:ext uri="{909E8E84-426E-40DD-AFC4-6F175D3DCCD1}">
+              <a14:hiddenFill xmlns:a14="http://schemas.microsoft.com/office/drawing/2010/main">
+                <a:solidFill>
+                  <a:schemeClr val="accent1"/>
+                </a:solidFill>
+              </a14:hiddenFill>
+            </a:ext>
+            <a:ext uri="{91240B29-F687-4F45-9708-019B960494DF}">
+              <a14:hiddenLine xmlns:a14="http://schemas.microsoft.com/office/drawing/2010/main" w="9525">
+                <a:solidFill>
+                  <a:schemeClr val="tx1"/>
+                </a:solidFill>
+                <a:miter lim="800000"/>
+                <a:headEnd/>
+                <a:tailEnd/>
+              </a14:hiddenLine>
+            </a:ext>
+            <a:ext uri="{AF507438-7753-43E0-B8FC-AC1667EBCBE1}">
+              <a14:hiddenEffects xmlns:a14="http://schemas.microsoft.com/office/drawing/2010/main">
+                <a:effectLst>
+                  <a:outerShdw dist="35921" dir="2700000" algn="ctr" rotWithShape="0">
+                    <a:schemeClr val="bg2"/>
+                  </a:outerShdw>
+                </a:effectLst>
+              </a14:hiddenEffects>
+            </a:ext>
+          </a:extLst>
+        </p:spPr>
+      </p:pic>
+      <p:sp>
+        <p:nvSpPr>
+          <p:cNvPr id="5" name="직사각형 4"/>
+          <p:cNvSpPr/>
+          <p:nvPr/>
+        </p:nvSpPr>
+        <p:spPr>
+          <a:xfrm>
+            <a:off x="3576092" y="4549130"/>
+            <a:ext cx="1077044" cy="156220"/>
+          </a:xfrm>
+          <a:prstGeom prst="rect">
+            <a:avLst/>
+          </a:prstGeom>
+          <a:solidFill>
+            <a:schemeClr val="bg1"/>
+          </a:solidFill>
+          <a:ln>
+            <a:solidFill>
+              <a:schemeClr val="bg1"/>
+            </a:solidFill>
+          </a:ln>
+        </p:spPr>
+        <p:style>
+          <a:lnRef idx="2">
+            <a:schemeClr val="accent1">
+              <a:shade val="50000"/>
+            </a:schemeClr>
+          </a:lnRef>
+          <a:fillRef idx="1">
+            <a:schemeClr val="accent1"/>
+          </a:fillRef>
+          <a:effectRef idx="0">
+            <a:schemeClr val="accent1"/>
+          </a:effectRef>
+          <a:fontRef idx="minor">
+            <a:schemeClr val="lt1"/>
+          </a:fontRef>
+        </p:style>
+        <p:txBody>
+          <a:bodyPr rtlCol="0" anchor="ctr"/>
+          <a:lstStyle/>
+          <a:p>
+            <a:pPr algn="ctr"/>
+            <a:endParaRPr lang="ko-KR" altLang="en-US"/>
+          </a:p>
+        </p:txBody>
+      </p:sp>
+    </p:spTree>
+    <p:extLst>
+      <p:ext uri="{BB962C8B-B14F-4D97-AF65-F5344CB8AC3E}">
+        <p14:creationId xmlns:p14="http://schemas.microsoft.com/office/powerpoint/2010/main" val="3524694103"/>
       </p:ext>
     </p:extLst>
   </p:cSld>

</xml_diff>